<commit_message>
Update capstone deck and guide for density and SDGs
</commit_message>
<xml_diff>
--- a/docs/Capstone_Presentation.pptx
+++ b/docs/Capstone_Presentation.pptx
@@ -2,20 +2,20 @@
 <file path=ppt/presentation.xml><?xml version="1.0" encoding="utf-8"?>
 <p:presentation xmlns:p="http://schemas.openxmlformats.org/presentationml/2006/main">
   <p:sldMasterIdLst>
-    <p:sldMasterId xmlns:r="http://schemas.openxmlformats.org/officeDocument/2006/relationships" id="2147483648" r:id="R02e84285ebc540b7"/>
+    <p:sldMasterId xmlns:r="http://schemas.openxmlformats.org/officeDocument/2006/relationships" id="2147483648" r:id="R96f211ac533c4159"/>
   </p:sldMasterIdLst>
   <p:notesMasterIdLst>
-    <p:notesMasterId xmlns:r="http://schemas.openxmlformats.org/officeDocument/2006/relationships" r:id="Re5f872df51b44f28"/>
+    <p:notesMasterId xmlns:r="http://schemas.openxmlformats.org/officeDocument/2006/relationships" r:id="Rc3b5774625ed4b49"/>
   </p:notesMasterIdLst>
   <p:sldIdLst>
-    <p:sldId xmlns:r="http://schemas.openxmlformats.org/officeDocument/2006/relationships" id="256" r:id="R2f327c5a206f4c14"/>
-    <p:sldId xmlns:r="http://schemas.openxmlformats.org/officeDocument/2006/relationships" id="257" r:id="Rc9082418b78d4823"/>
-    <p:sldId xmlns:r="http://schemas.openxmlformats.org/officeDocument/2006/relationships" id="258" r:id="Rbfd975cf06b24cbf"/>
-    <p:sldId xmlns:r="http://schemas.openxmlformats.org/officeDocument/2006/relationships" id="259" r:id="R6a060aefe8cb4409"/>
-    <p:sldId xmlns:r="http://schemas.openxmlformats.org/officeDocument/2006/relationships" id="260" r:id="R26dddc163d2349df"/>
-    <p:sldId xmlns:r="http://schemas.openxmlformats.org/officeDocument/2006/relationships" id="261" r:id="Rf2b38572ae394ea8"/>
-    <p:sldId xmlns:r="http://schemas.openxmlformats.org/officeDocument/2006/relationships" id="262" r:id="R67d967145ca64ff4"/>
-    <p:sldId xmlns:r="http://schemas.openxmlformats.org/officeDocument/2006/relationships" id="263" r:id="R8bdfab2bce2342b8"/>
+    <p:sldId xmlns:r="http://schemas.openxmlformats.org/officeDocument/2006/relationships" id="256" r:id="R2b3553f20eb54b88"/>
+    <p:sldId xmlns:r="http://schemas.openxmlformats.org/officeDocument/2006/relationships" id="257" r:id="R65c14ec088b14f83"/>
+    <p:sldId xmlns:r="http://schemas.openxmlformats.org/officeDocument/2006/relationships" id="258" r:id="Rbf3e3698dfbd438a"/>
+    <p:sldId xmlns:r="http://schemas.openxmlformats.org/officeDocument/2006/relationships" id="259" r:id="R9195ae24d5904621"/>
+    <p:sldId xmlns:r="http://schemas.openxmlformats.org/officeDocument/2006/relationships" id="260" r:id="R7dc7a22137e3416f"/>
+    <p:sldId xmlns:r="http://schemas.openxmlformats.org/officeDocument/2006/relationships" id="261" r:id="R4b5a0c16038a4657"/>
+    <p:sldId xmlns:r="http://schemas.openxmlformats.org/officeDocument/2006/relationships" id="262" r:id="R502f2872941a46a6"/>
+    <p:sldId xmlns:r="http://schemas.openxmlformats.org/officeDocument/2006/relationships" id="263" r:id="R12cd1f33e316481c"/>
   </p:sldIdLst>
   <p:sldSz cx="12192000" cy="6858000"/>
   <p:notesSz cx="6858000" cy="9144000"/>
@@ -539,27 +539,7 @@
           <a:lstStyle xmlns:a="http://schemas.openxmlformats.org/drawingml/2006/main"/>
           <a:p xmlns:a="http://schemas.openxmlformats.org/drawingml/2006/main">
             <a:r>
-              <a:t>Türkçe konuşmacı notu — 40 saniye.</a:t>
-            </a:r>
-          </a:p>
-          <a:p xmlns:a="http://schemas.openxmlformats.org/drawingml/2006/main">
-            <a:r>
-              <a:t/>
-            </a:r>
-          </a:p>
-          <a:p xmlns:a="http://schemas.openxmlformats.org/drawingml/2006/main">
-            <a:r>
-              <a:t>Hedef kullanıcımız yeni bir kafe açmayı düşünen girişimci. Temel soru, hangi bölgelerin saha incelemesine değer olduğu. Nüfus, yakın kurumlar, ulaşım ve rekabet bilgileri ayrı ayrı incelendiğinde karşılaştırma zorlaşıyor. Biz bunları ortak bir mekânsal birimde birleştiriyoruz. Pazarlama bağlantısı, işletmenin hedeflediği müşteri çevresine hangi bölgelerde daha iyi erişebileceğini değerlendirmesi. Ancak müşteri tercihlerini veya segment üyeliğini doğrudan gözlemlemiyoruz. Bu nedenle sonuç, müşteri talebinin kesin tahmini değil; girişimcinin kendi konseptiyle birlikte yorumlayacağı bir bölge eleme desteği.</a:t>
-            </a:r>
-          </a:p>
-          <a:p xmlns:a="http://schemas.openxmlformats.org/drawingml/2006/main">
-            <a:r>
-              <a:t/>
-            </a:r>
-          </a:p>
-          <a:p xmlns:a="http://schemas.openxmlformats.org/drawingml/2006/main">
-            <a:r>
-              <a:t>Sources: https://github.com/edasaruhan/SIC_AI_17_Capstone_Group_6/tree/58ce550c027d3ddce9f209fe3979bea849d5716a (app.py; src/scoring.py; src/cafe_similarity.py; docs/model_validation.md; data/processed). Technical baseline 58ce550; narrative updated 6 October 2026.</a:t>
+              <a:t>Yaklaşık 40 saniye. Ürün market-user-konum odaklıdır. Market çevredeki talep kaynaklarını ve benzer işletmeleri, user aday bölge seçen girişimciyi ve ulaşmak istediği müşteri çevresini, konum ise 300 metre hücreleri ve ulaşımı ifade eder. Bireysel müşteri izleme veya segment tahmini yapılmaz. KPI aday listesi hazırlama süresidir ve pilotta ölçülecektir.</a:t>
             </a:r>
           </a:p>
         </p:txBody>
@@ -719,27 +699,7 @@
           <a:lstStyle xmlns:a="http://schemas.openxmlformats.org/drawingml/2006/main"/>
           <a:p xmlns:a="http://schemas.openxmlformats.org/drawingml/2006/main">
             <a:r>
-              <a:t>Türkçe konuşmacı notu — 45 saniye.</a:t>
-            </a:r>
-          </a:p>
-          <a:p xmlns:a="http://schemas.openxmlformats.org/drawingml/2006/main">
-            <a:r>
-              <a:t/>
-            </a:r>
-          </a:p>
-          <a:p xmlns:a="http://schemas.openxmlformats.org/drawingml/2006/main">
-            <a:r>
-              <a:t>Ana sıralama, çok ölçütlü karar analizi yani MCDA ile yapılıyor. Varsayılan pozitif ağırlıklar talep için 0,45, erişim için 0,25 ve nüfus için 0,20; kendi toplamlarına bölünüyor. Grafikte normalize edilmiş paylar var. Restoran doygunluğu ve yoğun kafe rekabeti puanı azaltabiliyor. Kullanıcı senaryosunu değiştirdiğinde katkıları inceleyebiliyor; bu ağırlıklar satış verisinden öğrenilmiş değil. Random Forest ise ayrı bir karşılaştırma katmanı. On iki mekânsal girdiden, mevcut kafelerin bulunduğu çevrelere benzerliği değerlendiriyor. MCDA puanıyla birleştirilmiş kârlılık skoru üretmiyoruz. İki katman farklı sorulara yanıt verdiği için kullanıcı ikisini birlikte, ama ayrı anlamlarıyla yorumluyor.</a:t>
-            </a:r>
-          </a:p>
-          <a:p xmlns:a="http://schemas.openxmlformats.org/drawingml/2006/main">
-            <a:r>
-              <a:t/>
-            </a:r>
-          </a:p>
-          <a:p xmlns:a="http://schemas.openxmlformats.org/drawingml/2006/main">
-            <a:r>
-              <a:t>Sources: https://github.com/edasaruhan/SIC_AI_17_Capstone_Group_6/tree/58ce550c027d3ddce9f209fe3979bea849d5716a (app.py; src/scoring.py; src/cafe_similarity.py; docs/model_validation.md; data/processed). Technical baseline 58ce550; narrative updated 6 October 2026.</a:t>
+              <a:t>Yaklaşık 45 saniye. Talep 45, erişim 25, nüfus 20 temel ağırlıktır ve toplamlarıyla normalize edilir. Benzer yer yoğunluğu 500 m kafe sayısının tüm Çankaya maksimumuna oranıdır. Rekabet düzeyi sıfırken en fazla 5 puan ekler. Merkezde en az 2, 9 karede en az 6 ve 25 karede en az 13 kafe eşiklerinden her biri 5/3 puan düşürür. Herhangi bir eşik aşılırsa bonus kapanır. Eksik rekabet verisinde bonus verilmez ve puan geçici olur. Bu tercihler ticari veriden öğrenilmiş katsayılar değildir.</a:t>
             </a:r>
           </a:p>
         </p:txBody>
@@ -989,27 +949,7 @@
           <a:lstStyle xmlns:a="http://schemas.openxmlformats.org/drawingml/2006/main"/>
           <a:p xmlns:a="http://schemas.openxmlformats.org/drawingml/2006/main">
             <a:r>
-              <a:t>Türkçe konuşmacı notu — 35 saniye.</a:t>
-            </a:r>
-          </a:p>
-          <a:p xmlns:a="http://schemas.openxmlformats.org/drawingml/2006/main">
-            <a:r>
-              <a:t/>
-            </a:r>
-          </a:p>
-          <a:p xmlns:a="http://schemas.openxmlformats.org/drawingml/2006/main">
-            <a:r>
-              <a:t>Çalışan teslimat, yerel olarak açılabilen Streamlit uygulaması ve Docker yapılandırması. Teknik temel main sürümünde Python 3.11 ve 3.12 için 43 test başarılıydı. Testler puanlama, sızıntı önlemleri, çapraz doğrulama ve uygulama akışlarını kapsıyor. Buradaki son güncelleme anlatımı ve dokümantasyonu hizalıyor; karar algoritmasını değiştirmiyor. Sınırlamalarımız eksik OpenStreetMap kapsamı, dolaylı müşteri göstergeleri ve bazı eski veri katmanları. Serileştirilmiş model veya ayrı tahmin API’si yok; model uygulamada hesaplanıp önbelleğe alınıyor. Daha geniş kullanım için veri sürümleme, yönetim erişimi ve dağıtım doğrulaması gerekiyor.</a:t>
-            </a:r>
-          </a:p>
-          <a:p xmlns:a="http://schemas.openxmlformats.org/drawingml/2006/main">
-            <a:r>
-              <a:t/>
-            </a:r>
-          </a:p>
-          <a:p xmlns:a="http://schemas.openxmlformats.org/drawingml/2006/main">
-            <a:r>
-              <a:t>Sources: https://github.com/edasaruhan/SIC_AI_17_Capstone_Group_6/tree/58ce550c027d3ddce9f209fe3979bea849d5716a (app.py; src/scoring.py; src/cafe_similarity.py; docs/model_validation.md; data/processed). Technical baseline 58ce550; narrative updated 6 October 2026.</a:t>
+              <a:t>Yaklaşık 30 saniye. Güncel yerel kontrolde 47 test geçti. Önceki Python 3.11 ve 3.12 kanıtı 43 testlik eski temel sürüme aittir. Yoğunluk bonusu ve rekabet cezasının birlikte uygulanmaması, eksik veri, sıfır yoğunluk ve uygulama akışları test edildi. Sonraki adım girişimcilerin aynı aday liste görevini manuel ve panel kullanarak tamamladığı bir pilot olacaktır.</a:t>
             </a:r>
           </a:p>
         </p:txBody>
@@ -1079,27 +1019,7 @@
           <a:lstStyle xmlns:a="http://schemas.openxmlformats.org/drawingml/2006/main"/>
           <a:p xmlns:a="http://schemas.openxmlformats.org/drawingml/2006/main">
             <a:r>
-              <a:t>Türkçe konuşmacı notu — 35 saniye.</a:t>
-            </a:r>
-          </a:p>
-          <a:p xmlns:a="http://schemas.openxmlformats.org/drawingml/2006/main">
-            <a:r>
-              <a:t/>
-            </a:r>
-          </a:p>
-          <a:p xmlns:a="http://schemas.openxmlformats.org/drawingml/2006/main">
-            <a:r>
-              <a:t>Bir sonraki adım, pazarlama değerini ölçen küçük bir kullanıcı pilotu. Aynı bölge ve aynı kafe konsepti için önce manuel harita incelemesi, sonra uygulamayla aday eleme görevi verilebilir; sıra etkisini azaltmak için görev sırası dengelenmeli. Medyan tamamlama süresiyle birlikte kısa listenin kalite ve gerekçe yeterliliği incelenmeli. Hız kazanımı henüz kanıtlanmadı. Teknik tarafta daha güçlü mekânsal doğrulama ve veri kapsamı iyileştirmesi gerekli. Projenin vaadi, girişimcinin yerine karar vermek değil; erişim ve rekabet koşullarını görünür kılarak saha incelemesine daha odaklı hazırlanmasını sağlamak. Teşekkür ederim.</a:t>
-            </a:r>
-          </a:p>
-          <a:p xmlns:a="http://schemas.openxmlformats.org/drawingml/2006/main">
-            <a:r>
-              <a:t/>
-            </a:r>
-          </a:p>
-          <a:p xmlns:a="http://schemas.openxmlformats.org/drawingml/2006/main">
-            <a:r>
-              <a:t>Sources: https://github.com/edasaruhan/SIC_AI_17_Capstone_Group_6/tree/58ce550c027d3ddce9f209fe3979bea849d5716a (app.py; src/scoring.py; src/cafe_similarity.py; docs/model_validation.md; data/processed). Technical baseline 58ce550; narrative updated 6 October 2026.</a:t>
+              <a:t>Yaklaşık 40 saniye. Birleşmiş Milletler Hedef 3: Sağlık ve Kaliteli Yaşam, her yaşta sağlıklı yaşamı güvence altına almayı ve refahı desteklemeyi amaçlar. Park ve yaya erişimi üzerinden erişilebilir sosyal mekân planlamasıyla dolaylı bağlantı kuruyoruz. Sağlık sonucu ölçmüyoruz. Hedef 8: İnsana Yakışır İş ve Ekonomik Büyüme, sürdürülebilir ve kapsayıcı büyüme ile tam ve verimli istihdamı teşvik eder. Girişimcilerin pazar değerlendirmesini desteklemek bu amaçla ilişkilidir; istihdam veya iş kalitesi etkisi kanıtlanmadı. Hedef 11: Sürdürülebilir Şehirler ve Topluluklar, kapsayıcı, güvenli, dayanıklı ve sürdürülebilir yerleşimleri amaçlar. Ulaşım, park ve mahalle erişimini görünür kılıyoruz; güvenlik ve dayanıklılık için ek veri gerekir. Kaynaklar: https://sdgs.un.org/goals/goal3 https://sdgs.un.org/goals/goal8 https://sdgs.un.org/goals/goal11</a:t>
             </a:r>
           </a:p>
         </p:txBody>
@@ -1218,6 +1138,7 @@
                 <a:spcPts val="0"/>
               </a:spcAft>
               <a:buNone/>
+              <a:defRPr/>
             </a:lvl1pPr>
             <a:lvl2pPr marL="0" indent="0">
               <a:lnSpc>
@@ -1230,6 +1151,7 @@
                 <a:spcPts val="0"/>
               </a:spcAft>
               <a:buNone/>
+              <a:defRPr/>
             </a:lvl2pPr>
             <a:lvl3pPr marL="0" indent="0">
               <a:lnSpc>
@@ -1242,6 +1164,7 @@
                 <a:spcPts val="0"/>
               </a:spcAft>
               <a:buNone/>
+              <a:defRPr/>
             </a:lvl3pPr>
             <a:lvl4pPr marL="0" indent="0">
               <a:lnSpc>
@@ -1254,6 +1177,7 @@
                 <a:spcPts val="0"/>
               </a:spcAft>
               <a:buNone/>
+              <a:defRPr/>
             </a:lvl4pPr>
             <a:lvl5pPr marL="0" indent="0">
               <a:lnSpc>
@@ -1266,6 +1190,7 @@
                 <a:spcPts val="0"/>
               </a:spcAft>
               <a:buNone/>
+              <a:defRPr/>
             </a:lvl5pPr>
             <a:lvl6pPr marL="0" indent="0">
               <a:lnSpc>
@@ -1278,6 +1203,7 @@
                 <a:spcPts val="0"/>
               </a:spcAft>
               <a:buNone/>
+              <a:defRPr/>
             </a:lvl6pPr>
             <a:lvl7pPr marL="0" indent="0">
               <a:lnSpc>
@@ -1290,6 +1216,7 @@
                 <a:spcPts val="0"/>
               </a:spcAft>
               <a:buNone/>
+              <a:defRPr/>
             </a:lvl7pPr>
             <a:lvl8pPr marL="0" indent="0">
               <a:lnSpc>
@@ -1302,6 +1229,7 @@
                 <a:spcPts val="0"/>
               </a:spcAft>
               <a:buNone/>
+              <a:defRPr/>
             </a:lvl8pPr>
             <a:lvl9pPr marL="0" indent="0">
               <a:lnSpc>
@@ -1314,6 +1242,7 @@
                 <a:spcPts val="0"/>
               </a:spcAft>
               <a:buNone/>
+              <a:defRPr/>
             </a:lvl9pPr>
           </a:lstStyle>
           <a:p xmlns:a="http://schemas.openxmlformats.org/drawingml/2006/main"/>
@@ -1365,6 +1294,7 @@
                 <a:spcPts val="0"/>
               </a:spcAft>
               <a:buNone/>
+              <a:defRPr/>
             </a:lvl1pPr>
             <a:lvl2pPr marL="0" indent="0">
               <a:lnSpc>
@@ -1377,6 +1307,7 @@
                 <a:spcPts val="0"/>
               </a:spcAft>
               <a:buNone/>
+              <a:defRPr/>
             </a:lvl2pPr>
             <a:lvl3pPr marL="0" indent="0">
               <a:lnSpc>
@@ -1389,6 +1320,7 @@
                 <a:spcPts val="0"/>
               </a:spcAft>
               <a:buNone/>
+              <a:defRPr/>
             </a:lvl3pPr>
             <a:lvl4pPr marL="0" indent="0">
               <a:lnSpc>
@@ -1401,6 +1333,7 @@
                 <a:spcPts val="0"/>
               </a:spcAft>
               <a:buNone/>
+              <a:defRPr/>
             </a:lvl4pPr>
             <a:lvl5pPr marL="0" indent="0">
               <a:lnSpc>
@@ -1413,6 +1346,7 @@
                 <a:spcPts val="0"/>
               </a:spcAft>
               <a:buNone/>
+              <a:defRPr/>
             </a:lvl5pPr>
             <a:lvl6pPr marL="0" indent="0">
               <a:lnSpc>
@@ -1425,6 +1359,7 @@
                 <a:spcPts val="0"/>
               </a:spcAft>
               <a:buNone/>
+              <a:defRPr/>
             </a:lvl6pPr>
             <a:lvl7pPr marL="0" indent="0">
               <a:lnSpc>
@@ -1437,6 +1372,7 @@
                 <a:spcPts val="0"/>
               </a:spcAft>
               <a:buNone/>
+              <a:defRPr/>
             </a:lvl7pPr>
             <a:lvl8pPr marL="0" indent="0">
               <a:lnSpc>
@@ -1449,6 +1385,7 @@
                 <a:spcPts val="0"/>
               </a:spcAft>
               <a:buNone/>
+              <a:defRPr/>
             </a:lvl8pPr>
             <a:lvl9pPr marL="0" indent="0">
               <a:lnSpc>
@@ -1461,6 +1398,7 @@
                 <a:spcPts val="0"/>
               </a:spcAft>
               <a:buNone/>
+              <a:defRPr/>
             </a:lvl9pPr>
           </a:lstStyle>
           <a:p xmlns:a="http://schemas.openxmlformats.org/drawingml/2006/main"/>
@@ -1560,6 +1498,7 @@
                 <a:spcPts val="0"/>
               </a:spcAft>
               <a:buNone/>
+              <a:defRPr/>
             </a:lvl1pPr>
             <a:lvl2pPr marL="0" indent="0">
               <a:lnSpc>
@@ -1572,6 +1511,7 @@
                 <a:spcPts val="0"/>
               </a:spcAft>
               <a:buNone/>
+              <a:defRPr/>
             </a:lvl2pPr>
             <a:lvl3pPr marL="0" indent="0">
               <a:lnSpc>
@@ -1584,6 +1524,7 @@
                 <a:spcPts val="0"/>
               </a:spcAft>
               <a:buNone/>
+              <a:defRPr/>
             </a:lvl3pPr>
             <a:lvl4pPr marL="0" indent="0">
               <a:lnSpc>
@@ -1596,6 +1537,7 @@
                 <a:spcPts val="0"/>
               </a:spcAft>
               <a:buNone/>
+              <a:defRPr/>
             </a:lvl4pPr>
             <a:lvl5pPr marL="0" indent="0">
               <a:lnSpc>
@@ -1608,6 +1550,7 @@
                 <a:spcPts val="0"/>
               </a:spcAft>
               <a:buNone/>
+              <a:defRPr/>
             </a:lvl5pPr>
             <a:lvl6pPr marL="0" indent="0">
               <a:lnSpc>
@@ -1620,6 +1563,7 @@
                 <a:spcPts val="0"/>
               </a:spcAft>
               <a:buNone/>
+              <a:defRPr/>
             </a:lvl6pPr>
             <a:lvl7pPr marL="0" indent="0">
               <a:lnSpc>
@@ -1632,6 +1576,7 @@
                 <a:spcPts val="0"/>
               </a:spcAft>
               <a:buNone/>
+              <a:defRPr/>
             </a:lvl7pPr>
             <a:lvl8pPr marL="0" indent="0">
               <a:lnSpc>
@@ -1644,6 +1589,7 @@
                 <a:spcPts val="0"/>
               </a:spcAft>
               <a:buNone/>
+              <a:defRPr/>
             </a:lvl8pPr>
             <a:lvl9pPr marL="0" indent="0">
               <a:lnSpc>
@@ -1656,6 +1602,7 @@
                 <a:spcPts val="0"/>
               </a:spcAft>
               <a:buNone/>
+              <a:defRPr/>
             </a:lvl9pPr>
           </a:lstStyle>
           <a:p xmlns:a="http://schemas.openxmlformats.org/drawingml/2006/main"/>
@@ -1755,6 +1702,7 @@
                 <a:spcPts val="0"/>
               </a:spcAft>
               <a:buNone/>
+              <a:defRPr/>
             </a:lvl1pPr>
             <a:lvl2pPr marL="0" indent="0">
               <a:lnSpc>
@@ -1767,6 +1715,7 @@
                 <a:spcPts val="0"/>
               </a:spcAft>
               <a:buNone/>
+              <a:defRPr/>
             </a:lvl2pPr>
             <a:lvl3pPr marL="0" indent="0">
               <a:lnSpc>
@@ -1779,6 +1728,7 @@
                 <a:spcPts val="0"/>
               </a:spcAft>
               <a:buNone/>
+              <a:defRPr/>
             </a:lvl3pPr>
             <a:lvl4pPr marL="0" indent="0">
               <a:lnSpc>
@@ -1791,6 +1741,7 @@
                 <a:spcPts val="0"/>
               </a:spcAft>
               <a:buNone/>
+              <a:defRPr/>
             </a:lvl4pPr>
             <a:lvl5pPr marL="0" indent="0">
               <a:lnSpc>
@@ -1803,6 +1754,7 @@
                 <a:spcPts val="0"/>
               </a:spcAft>
               <a:buNone/>
+              <a:defRPr/>
             </a:lvl5pPr>
             <a:lvl6pPr marL="0" indent="0">
               <a:lnSpc>
@@ -1815,6 +1767,7 @@
                 <a:spcPts val="0"/>
               </a:spcAft>
               <a:buNone/>
+              <a:defRPr/>
             </a:lvl6pPr>
             <a:lvl7pPr marL="0" indent="0">
               <a:lnSpc>
@@ -1827,6 +1780,7 @@
                 <a:spcPts val="0"/>
               </a:spcAft>
               <a:buNone/>
+              <a:defRPr/>
             </a:lvl7pPr>
             <a:lvl8pPr marL="0" indent="0">
               <a:lnSpc>
@@ -1839,6 +1793,7 @@
                 <a:spcPts val="0"/>
               </a:spcAft>
               <a:buNone/>
+              <a:defRPr/>
             </a:lvl8pPr>
             <a:lvl9pPr marL="0" indent="0">
               <a:lnSpc>
@@ -1851,6 +1806,7 @@
                 <a:spcPts val="0"/>
               </a:spcAft>
               <a:buNone/>
+              <a:defRPr/>
             </a:lvl9pPr>
           </a:lstStyle>
           <a:p xmlns:a="http://schemas.openxmlformats.org/drawingml/2006/main"/>
@@ -1902,6 +1858,7 @@
                 <a:spcPts val="1200"/>
               </a:spcAft>
               <a:buChar char="•"/>
+              <a:defRPr/>
             </a:lvl1pPr>
             <a:lvl2pPr marL="533400" indent="-228600">
               <a:lnSpc>
@@ -1914,6 +1871,7 @@
                 <a:spcPts val="1200"/>
               </a:spcAft>
               <a:buChar char="•"/>
+              <a:defRPr/>
             </a:lvl2pPr>
             <a:lvl3pPr marL="838200" indent="-228600">
               <a:lnSpc>
@@ -1926,6 +1884,7 @@
                 <a:spcPts val="1200"/>
               </a:spcAft>
               <a:buChar char="•"/>
+              <a:defRPr/>
             </a:lvl3pPr>
             <a:lvl4pPr marL="1143000" indent="-228600">
               <a:lnSpc>
@@ -1938,6 +1897,7 @@
                 <a:spcPts val="1200"/>
               </a:spcAft>
               <a:buChar char="•"/>
+              <a:defRPr/>
             </a:lvl4pPr>
             <a:lvl5pPr marL="1447800" indent="-228600">
               <a:lnSpc>
@@ -1950,6 +1910,7 @@
                 <a:spcPts val="1200"/>
               </a:spcAft>
               <a:buChar char="•"/>
+              <a:defRPr/>
             </a:lvl5pPr>
             <a:lvl6pPr marL="1752600" indent="-228600">
               <a:lnSpc>
@@ -1962,6 +1923,7 @@
                 <a:spcPts val="1200"/>
               </a:spcAft>
               <a:buChar char="•"/>
+              <a:defRPr/>
             </a:lvl6pPr>
             <a:lvl7pPr marL="2057400" indent="-228600">
               <a:lnSpc>
@@ -1974,6 +1936,7 @@
                 <a:spcPts val="1200"/>
               </a:spcAft>
               <a:buChar char="•"/>
+              <a:defRPr/>
             </a:lvl7pPr>
             <a:lvl8pPr marL="2362200" indent="-228600">
               <a:lnSpc>
@@ -1986,6 +1949,7 @@
                 <a:spcPts val="1200"/>
               </a:spcAft>
               <a:buChar char="•"/>
+              <a:defRPr/>
             </a:lvl8pPr>
             <a:lvl9pPr marL="2667000" indent="-228600">
               <a:lnSpc>
@@ -1998,6 +1962,7 @@
                 <a:spcPts val="1200"/>
               </a:spcAft>
               <a:buChar char="•"/>
+              <a:defRPr/>
             </a:lvl9pPr>
           </a:lstStyle>
           <a:p xmlns:a="http://schemas.openxmlformats.org/drawingml/2006/main"/>
@@ -2097,6 +2062,7 @@
                 <a:spcPts val="0"/>
               </a:spcAft>
               <a:buNone/>
+              <a:defRPr/>
             </a:lvl1pPr>
             <a:lvl2pPr marL="0" indent="0">
               <a:lnSpc>
@@ -2109,6 +2075,7 @@
                 <a:spcPts val="0"/>
               </a:spcAft>
               <a:buNone/>
+              <a:defRPr/>
             </a:lvl2pPr>
             <a:lvl3pPr marL="0" indent="0">
               <a:lnSpc>
@@ -2121,6 +2088,7 @@
                 <a:spcPts val="0"/>
               </a:spcAft>
               <a:buNone/>
+              <a:defRPr/>
             </a:lvl3pPr>
             <a:lvl4pPr marL="0" indent="0">
               <a:lnSpc>
@@ -2133,6 +2101,7 @@
                 <a:spcPts val="0"/>
               </a:spcAft>
               <a:buNone/>
+              <a:defRPr/>
             </a:lvl4pPr>
             <a:lvl5pPr marL="0" indent="0">
               <a:lnSpc>
@@ -2145,6 +2114,7 @@
                 <a:spcPts val="0"/>
               </a:spcAft>
               <a:buNone/>
+              <a:defRPr/>
             </a:lvl5pPr>
             <a:lvl6pPr marL="0" indent="0">
               <a:lnSpc>
@@ -2157,6 +2127,7 @@
                 <a:spcPts val="0"/>
               </a:spcAft>
               <a:buNone/>
+              <a:defRPr/>
             </a:lvl6pPr>
             <a:lvl7pPr marL="0" indent="0">
               <a:lnSpc>
@@ -2169,6 +2140,7 @@
                 <a:spcPts val="0"/>
               </a:spcAft>
               <a:buNone/>
+              <a:defRPr/>
             </a:lvl7pPr>
             <a:lvl8pPr marL="0" indent="0">
               <a:lnSpc>
@@ -2181,6 +2153,7 @@
                 <a:spcPts val="0"/>
               </a:spcAft>
               <a:buNone/>
+              <a:defRPr/>
             </a:lvl8pPr>
             <a:lvl9pPr marL="0" indent="0">
               <a:lnSpc>
@@ -2193,6 +2166,7 @@
                 <a:spcPts val="0"/>
               </a:spcAft>
               <a:buNone/>
+              <a:defRPr/>
             </a:lvl9pPr>
           </a:lstStyle>
           <a:p xmlns:a="http://schemas.openxmlformats.org/drawingml/2006/main"/>
@@ -2244,6 +2218,7 @@
                 <a:spcPts val="1200"/>
               </a:spcAft>
               <a:buChar char="•"/>
+              <a:defRPr/>
             </a:lvl1pPr>
             <a:lvl2pPr marL="533400" indent="-228600">
               <a:lnSpc>
@@ -2256,6 +2231,7 @@
                 <a:spcPts val="1200"/>
               </a:spcAft>
               <a:buChar char="•"/>
+              <a:defRPr/>
             </a:lvl2pPr>
             <a:lvl3pPr marL="838200" indent="-228600">
               <a:lnSpc>
@@ -2268,6 +2244,7 @@
                 <a:spcPts val="1200"/>
               </a:spcAft>
               <a:buChar char="•"/>
+              <a:defRPr/>
             </a:lvl3pPr>
             <a:lvl4pPr marL="1143000" indent="-228600">
               <a:lnSpc>
@@ -2280,6 +2257,7 @@
                 <a:spcPts val="1200"/>
               </a:spcAft>
               <a:buChar char="•"/>
+              <a:defRPr/>
             </a:lvl4pPr>
             <a:lvl5pPr marL="1447800" indent="-228600">
               <a:lnSpc>
@@ -2292,6 +2270,7 @@
                 <a:spcPts val="1200"/>
               </a:spcAft>
               <a:buChar char="•"/>
+              <a:defRPr/>
             </a:lvl5pPr>
             <a:lvl6pPr marL="1752600" indent="-228600">
               <a:lnSpc>
@@ -2304,6 +2283,7 @@
                 <a:spcPts val="1200"/>
               </a:spcAft>
               <a:buChar char="•"/>
+              <a:defRPr/>
             </a:lvl6pPr>
             <a:lvl7pPr marL="2057400" indent="-228600">
               <a:lnSpc>
@@ -2316,6 +2296,7 @@
                 <a:spcPts val="1200"/>
               </a:spcAft>
               <a:buChar char="•"/>
+              <a:defRPr/>
             </a:lvl7pPr>
             <a:lvl8pPr marL="2362200" indent="-228600">
               <a:lnSpc>
@@ -2328,6 +2309,7 @@
                 <a:spcPts val="1200"/>
               </a:spcAft>
               <a:buChar char="•"/>
+              <a:defRPr/>
             </a:lvl8pPr>
             <a:lvl9pPr marL="2667000" indent="-228600">
               <a:lnSpc>
@@ -2340,6 +2322,7 @@
                 <a:spcPts val="1200"/>
               </a:spcAft>
               <a:buChar char="•"/>
+              <a:defRPr/>
             </a:lvl9pPr>
           </a:lstStyle>
           <a:p xmlns:a="http://schemas.openxmlformats.org/drawingml/2006/main"/>
@@ -2391,6 +2374,7 @@
                 <a:spcPts val="1200"/>
               </a:spcAft>
               <a:buChar char="•"/>
+              <a:defRPr/>
             </a:lvl1pPr>
             <a:lvl2pPr marL="533400" indent="-228600">
               <a:lnSpc>
@@ -2403,6 +2387,7 @@
                 <a:spcPts val="1200"/>
               </a:spcAft>
               <a:buChar char="•"/>
+              <a:defRPr/>
             </a:lvl2pPr>
             <a:lvl3pPr marL="838200" indent="-228600">
               <a:lnSpc>
@@ -2415,6 +2400,7 @@
                 <a:spcPts val="1200"/>
               </a:spcAft>
               <a:buChar char="•"/>
+              <a:defRPr/>
             </a:lvl3pPr>
             <a:lvl4pPr marL="1143000" indent="-228600">
               <a:lnSpc>
@@ -2427,6 +2413,7 @@
                 <a:spcPts val="1200"/>
               </a:spcAft>
               <a:buChar char="•"/>
+              <a:defRPr/>
             </a:lvl4pPr>
             <a:lvl5pPr marL="1447800" indent="-228600">
               <a:lnSpc>
@@ -2439,6 +2426,7 @@
                 <a:spcPts val="1200"/>
               </a:spcAft>
               <a:buChar char="•"/>
+              <a:defRPr/>
             </a:lvl5pPr>
             <a:lvl6pPr marL="1752600" indent="-228600">
               <a:lnSpc>
@@ -2451,6 +2439,7 @@
                 <a:spcPts val="1200"/>
               </a:spcAft>
               <a:buChar char="•"/>
+              <a:defRPr/>
             </a:lvl6pPr>
             <a:lvl7pPr marL="2057400" indent="-228600">
               <a:lnSpc>
@@ -2463,6 +2452,7 @@
                 <a:spcPts val="1200"/>
               </a:spcAft>
               <a:buChar char="•"/>
+              <a:defRPr/>
             </a:lvl7pPr>
             <a:lvl8pPr marL="2362200" indent="-228600">
               <a:lnSpc>
@@ -2475,6 +2465,7 @@
                 <a:spcPts val="1200"/>
               </a:spcAft>
               <a:buChar char="•"/>
+              <a:defRPr/>
             </a:lvl8pPr>
             <a:lvl9pPr marL="2667000" indent="-228600">
               <a:lnSpc>
@@ -2487,6 +2478,7 @@
                 <a:spcPts val="1200"/>
               </a:spcAft>
               <a:buChar char="•"/>
+              <a:defRPr/>
             </a:lvl9pPr>
           </a:lstStyle>
           <a:p xmlns:a="http://schemas.openxmlformats.org/drawingml/2006/main"/>
@@ -2586,6 +2578,7 @@
                 <a:spcPts val="0"/>
               </a:spcAft>
               <a:buNone/>
+              <a:defRPr/>
             </a:lvl1pPr>
             <a:lvl2pPr marL="0" indent="0">
               <a:lnSpc>
@@ -2598,6 +2591,7 @@
                 <a:spcPts val="0"/>
               </a:spcAft>
               <a:buNone/>
+              <a:defRPr/>
             </a:lvl2pPr>
             <a:lvl3pPr marL="0" indent="0">
               <a:lnSpc>
@@ -2610,6 +2604,7 @@
                 <a:spcPts val="0"/>
               </a:spcAft>
               <a:buNone/>
+              <a:defRPr/>
             </a:lvl3pPr>
             <a:lvl4pPr marL="0" indent="0">
               <a:lnSpc>
@@ -2622,6 +2617,7 @@
                 <a:spcPts val="0"/>
               </a:spcAft>
               <a:buNone/>
+              <a:defRPr/>
             </a:lvl4pPr>
             <a:lvl5pPr marL="0" indent="0">
               <a:lnSpc>
@@ -2634,6 +2630,7 @@
                 <a:spcPts val="0"/>
               </a:spcAft>
               <a:buNone/>
+              <a:defRPr/>
             </a:lvl5pPr>
             <a:lvl6pPr marL="0" indent="0">
               <a:lnSpc>
@@ -2646,6 +2643,7 @@
                 <a:spcPts val="0"/>
               </a:spcAft>
               <a:buNone/>
+              <a:defRPr/>
             </a:lvl6pPr>
             <a:lvl7pPr marL="0" indent="0">
               <a:lnSpc>
@@ -2658,6 +2656,7 @@
                 <a:spcPts val="0"/>
               </a:spcAft>
               <a:buNone/>
+              <a:defRPr/>
             </a:lvl7pPr>
             <a:lvl8pPr marL="0" indent="0">
               <a:lnSpc>
@@ -2670,6 +2669,7 @@
                 <a:spcPts val="0"/>
               </a:spcAft>
               <a:buNone/>
+              <a:defRPr/>
             </a:lvl8pPr>
             <a:lvl9pPr marL="0" indent="0">
               <a:lnSpc>
@@ -2682,6 +2682,7 @@
                 <a:spcPts val="0"/>
               </a:spcAft>
               <a:buNone/>
+              <a:defRPr/>
             </a:lvl9pPr>
           </a:lstStyle>
           <a:p xmlns:a="http://schemas.openxmlformats.org/drawingml/2006/main"/>
@@ -2733,6 +2734,7 @@
                 <a:spcPts val="1200"/>
               </a:spcAft>
               <a:buChar char="•"/>
+              <a:defRPr/>
             </a:lvl1pPr>
             <a:lvl2pPr marL="533400" indent="-228600">
               <a:lnSpc>
@@ -2745,6 +2747,7 @@
                 <a:spcPts val="1200"/>
               </a:spcAft>
               <a:buChar char="•"/>
+              <a:defRPr/>
             </a:lvl2pPr>
             <a:lvl3pPr marL="838200" indent="-228600">
               <a:lnSpc>
@@ -2757,6 +2760,7 @@
                 <a:spcPts val="1200"/>
               </a:spcAft>
               <a:buChar char="•"/>
+              <a:defRPr/>
             </a:lvl3pPr>
             <a:lvl4pPr marL="1143000" indent="-228600">
               <a:lnSpc>
@@ -2769,6 +2773,7 @@
                 <a:spcPts val="1200"/>
               </a:spcAft>
               <a:buChar char="•"/>
+              <a:defRPr/>
             </a:lvl4pPr>
             <a:lvl5pPr marL="1447800" indent="-228600">
               <a:lnSpc>
@@ -2781,6 +2786,7 @@
                 <a:spcPts val="1200"/>
               </a:spcAft>
               <a:buChar char="•"/>
+              <a:defRPr/>
             </a:lvl5pPr>
             <a:lvl6pPr marL="1752600" indent="-228600">
               <a:lnSpc>
@@ -2793,6 +2799,7 @@
                 <a:spcPts val="1200"/>
               </a:spcAft>
               <a:buChar char="•"/>
+              <a:defRPr/>
             </a:lvl6pPr>
             <a:lvl7pPr marL="2057400" indent="-228600">
               <a:lnSpc>
@@ -2805,6 +2812,7 @@
                 <a:spcPts val="1200"/>
               </a:spcAft>
               <a:buChar char="•"/>
+              <a:defRPr/>
             </a:lvl7pPr>
             <a:lvl8pPr marL="2362200" indent="-228600">
               <a:lnSpc>
@@ -2817,6 +2825,7 @@
                 <a:spcPts val="1200"/>
               </a:spcAft>
               <a:buChar char="•"/>
+              <a:defRPr/>
             </a:lvl8pPr>
             <a:lvl9pPr marL="2667000" indent="-228600">
               <a:lnSpc>
@@ -2829,6 +2838,7 @@
                 <a:spcPts val="1200"/>
               </a:spcAft>
               <a:buChar char="•"/>
+              <a:defRPr/>
             </a:lvl9pPr>
           </a:lstStyle>
           <a:p xmlns:a="http://schemas.openxmlformats.org/drawingml/2006/main"/>
@@ -2877,12 +2887,12 @@
   </p:cSld>
   <p:clrMap bg1="lt1" tx1="dk1" bg2="lt2" tx2="dk2" accent1="accent1" accent2="accent2" accent3="accent3" accent4="accent4" accent5="accent5" accent6="accent6" hlink="hlink" folHlink="folHlink"/>
   <p:sldLayoutIdLst>
-    <p:sldLayoutId xmlns:r="http://schemas.openxmlformats.org/officeDocument/2006/relationships" id="2147483649" r:id="R83f6c211229d49c6"/>
-    <p:sldLayoutId xmlns:r="http://schemas.openxmlformats.org/officeDocument/2006/relationships" id="2147483650" r:id="Ra16da63a47fe49d2"/>
-    <p:sldLayoutId xmlns:r="http://schemas.openxmlformats.org/officeDocument/2006/relationships" id="2147483651" r:id="Rc71b7720748a474d"/>
-    <p:sldLayoutId xmlns:r="http://schemas.openxmlformats.org/officeDocument/2006/relationships" id="2147483652" r:id="R48b9d68f6e1c4829"/>
-    <p:sldLayoutId xmlns:r="http://schemas.openxmlformats.org/officeDocument/2006/relationships" id="2147483653" r:id="Rb6f15799aa1c4e0e"/>
-    <p:sldLayoutId xmlns:r="http://schemas.openxmlformats.org/officeDocument/2006/relationships" id="2147483654" r:id="Rf49b42d049b149c3"/>
+    <p:sldLayoutId xmlns:r="http://schemas.openxmlformats.org/officeDocument/2006/relationships" id="2147483649" r:id="Rda39bd49f2dd4912"/>
+    <p:sldLayoutId xmlns:r="http://schemas.openxmlformats.org/officeDocument/2006/relationships" id="2147483650" r:id="R0544a99233214c06"/>
+    <p:sldLayoutId xmlns:r="http://schemas.openxmlformats.org/officeDocument/2006/relationships" id="2147483651" r:id="R095de27b1cc34039"/>
+    <p:sldLayoutId xmlns:r="http://schemas.openxmlformats.org/officeDocument/2006/relationships" id="2147483652" r:id="Rc7297ca917cb42c9"/>
+    <p:sldLayoutId xmlns:r="http://schemas.openxmlformats.org/officeDocument/2006/relationships" id="2147483653" r:id="R1fe8cbba22a44457"/>
+    <p:sldLayoutId xmlns:r="http://schemas.openxmlformats.org/officeDocument/2006/relationships" id="2147483654" r:id="Rf4e451d1b87c4bc0"/>
   </p:sldLayoutIdLst>
   <p:txStyles>
     <p:titleStyle>
@@ -3969,6 +3979,7 @@
           <a:lstStyle xmlns:a="http://schemas.openxmlformats.org/drawingml/2006/main"/>
           <a:p xmlns:a="http://schemas.openxmlformats.org/drawingml/2006/main">
             <a:pPr>
+              <a:buNone/>
               <a:defRPr sz="1350" b="1">
                 <a:solidFill>
                   <a:srgbClr val="167AAB"/>
@@ -4026,6 +4037,7 @@
           <a:lstStyle xmlns:a="http://schemas.openxmlformats.org/drawingml/2006/main"/>
           <a:p xmlns:a="http://schemas.openxmlformats.org/drawingml/2006/main">
             <a:pPr>
+              <a:buNone/>
               <a:defRPr sz="3450" b="1">
                 <a:solidFill>
                   <a:srgbClr val="142E44"/>
@@ -4083,6 +4095,7 @@
           <a:lstStyle xmlns:a="http://schemas.openxmlformats.org/drawingml/2006/main"/>
           <a:p xmlns:a="http://schemas.openxmlformats.org/drawingml/2006/main">
             <a:pPr>
+              <a:buNone/>
               <a:defRPr sz="1800" b="0">
                 <a:solidFill>
                   <a:srgbClr val="526879"/>
@@ -4140,6 +4153,7 @@
           <a:lstStyle xmlns:a="http://schemas.openxmlformats.org/drawingml/2006/main"/>
           <a:p xmlns:a="http://schemas.openxmlformats.org/drawingml/2006/main">
             <a:pPr>
+              <a:buNone/>
               <a:defRPr sz="1200" b="0">
                 <a:solidFill>
                   <a:srgbClr val="526879"/>
@@ -4197,6 +4211,7 @@
           <a:lstStyle xmlns:a="http://schemas.openxmlformats.org/drawingml/2006/main"/>
           <a:p xmlns:a="http://schemas.openxmlformats.org/drawingml/2006/main">
             <a:pPr>
+              <a:buNone/>
               <a:defRPr sz="1200" b="0">
                 <a:solidFill>
                   <a:srgbClr val="526879"/>
@@ -4254,6 +4269,7 @@
           <a:lstStyle xmlns:a="http://schemas.openxmlformats.org/drawingml/2006/main"/>
           <a:p xmlns:a="http://schemas.openxmlformats.org/drawingml/2006/main">
             <a:pPr>
+              <a:buNone/>
               <a:defRPr sz="3300" b="1">
                 <a:solidFill>
                   <a:srgbClr val="142E44"/>
@@ -4277,6 +4293,7 @@
           </a:p>
           <a:p xmlns:a="http://schemas.openxmlformats.org/drawingml/2006/main">
             <a:pPr>
+              <a:buNone/>
               <a:defRPr sz="3300" b="1">
                 <a:solidFill>
                   <a:srgbClr val="142E44"/>
@@ -4300,6 +4317,7 @@
           </a:p>
           <a:p xmlns:a="http://schemas.openxmlformats.org/drawingml/2006/main">
             <a:pPr>
+              <a:buNone/>
               <a:defRPr sz="3300" b="1">
                 <a:solidFill>
                   <a:srgbClr val="142E44"/>
@@ -4357,6 +4375,7 @@
           <a:lstStyle xmlns:a="http://schemas.openxmlformats.org/drawingml/2006/main"/>
           <a:p xmlns:a="http://schemas.openxmlformats.org/drawingml/2006/main">
             <a:pPr>
+              <a:buNone/>
               <a:defRPr sz="1950" b="0">
                 <a:solidFill>
                   <a:srgbClr val="167AAB"/>
@@ -4443,6 +4462,7 @@
           <a:lstStyle xmlns:a="http://schemas.openxmlformats.org/drawingml/2006/main"/>
           <a:p xmlns:a="http://schemas.openxmlformats.org/drawingml/2006/main">
             <a:pPr>
+              <a:buNone/>
               <a:defRPr sz="1350" b="1">
                 <a:solidFill>
                   <a:srgbClr val="167AAB"/>
@@ -4500,6 +4520,7 @@
           <a:lstStyle xmlns:a="http://schemas.openxmlformats.org/drawingml/2006/main"/>
           <a:p xmlns:a="http://schemas.openxmlformats.org/drawingml/2006/main">
             <a:pPr>
+              <a:buNone/>
               <a:defRPr sz="3450" b="1">
                 <a:solidFill>
                   <a:srgbClr val="142E44"/>
@@ -4556,7 +4577,8 @@
           </a:bodyPr>
           <a:lstStyle xmlns:a="http://schemas.openxmlformats.org/drawingml/2006/main"/>
           <a:p xmlns:a="http://schemas.openxmlformats.org/drawingml/2006/main">
-            <a:pPr>
+            <a:pPr algn="l">
+              <a:buNone/>
               <a:defRPr sz="1800" b="0">
                 <a:solidFill>
                   <a:srgbClr val="526879"/>
@@ -4575,7 +4597,7 @@
                 <a:ea typeface="DejaVu Sans"/>
                 <a:cs typeface="DejaVu Sans"/>
               </a:rPr>
-              <a:t>Geographic market planning: the “Place” dimension of marketing.</a:t>
+              <a:t>Market–user–location planning for the “Place” dimension of marketing.</a:t>
             </a:r>
           </a:p>
         </p:txBody>
@@ -4614,6 +4636,7 @@
           <a:lstStyle xmlns:a="http://schemas.openxmlformats.org/drawingml/2006/main"/>
           <a:p xmlns:a="http://schemas.openxmlformats.org/drawingml/2006/main">
             <a:pPr>
+              <a:buNone/>
               <a:defRPr sz="1200" b="0">
                 <a:solidFill>
                   <a:srgbClr val="526879"/>
@@ -4671,6 +4694,7 @@
           <a:lstStyle xmlns:a="http://schemas.openxmlformats.org/drawingml/2006/main"/>
           <a:p xmlns:a="http://schemas.openxmlformats.org/drawingml/2006/main">
             <a:pPr>
+              <a:buNone/>
               <a:defRPr sz="1200" b="0">
                 <a:solidFill>
                   <a:srgbClr val="526879"/>
@@ -4728,6 +4752,7 @@
           <a:lstStyle xmlns:a="http://schemas.openxmlformats.org/drawingml/2006/main"/>
           <a:p xmlns:a="http://schemas.openxmlformats.org/drawingml/2006/main">
             <a:pPr>
+              <a:buNone/>
               <a:defRPr sz="2250" b="1">
                 <a:solidFill>
                   <a:srgbClr val="167AAB"/>
@@ -4785,6 +4810,7 @@
           <a:lstStyle xmlns:a="http://schemas.openxmlformats.org/drawingml/2006/main"/>
           <a:p xmlns:a="http://schemas.openxmlformats.org/drawingml/2006/main">
             <a:pPr>
+              <a:buNone/>
               <a:defRPr sz="2100" b="0">
                 <a:solidFill>
                   <a:srgbClr val="142E44"/>
@@ -4808,6 +4834,7 @@
           </a:p>
           <a:p xmlns:a="http://schemas.openxmlformats.org/drawingml/2006/main">
             <a:pPr>
+              <a:buNone/>
               <a:defRPr sz="2100" b="0">
                 <a:solidFill>
                   <a:srgbClr val="142E44"/>
@@ -4865,6 +4892,7 @@
           <a:lstStyle xmlns:a="http://schemas.openxmlformats.org/drawingml/2006/main"/>
           <a:p xmlns:a="http://schemas.openxmlformats.org/drawingml/2006/main">
             <a:pPr>
+              <a:buNone/>
               <a:defRPr sz="2250" b="1">
                 <a:solidFill>
                   <a:srgbClr val="167AAB"/>
@@ -4921,72 +4949,75 @@
           </a:bodyPr>
           <a:lstStyle xmlns:a="http://schemas.openxmlformats.org/drawingml/2006/main"/>
           <a:p xmlns:a="http://schemas.openxmlformats.org/drawingml/2006/main">
-            <a:pPr>
-              <a:defRPr sz="2100" b="0">
-                <a:solidFill>
-                  <a:srgbClr val="142E44"/>
-                </a:solidFill>
-                <a:latin typeface="DejaVu Sans"/>
-                <a:ea typeface="DejaVu Sans"/>
-                <a:cs typeface="DejaVu Sans"/>
-              </a:defRPr>
-            </a:pPr>
-            <a:r>
-              <a:rPr sz="2100" b="0">
-                <a:solidFill>
-                  <a:srgbClr val="142E44"/>
-                </a:solidFill>
-                <a:latin typeface="DejaVu Sans"/>
-                <a:ea typeface="DejaVu Sans"/>
-                <a:cs typeface="DejaVu Sans"/>
-              </a:rPr>
-              <a:t>Access to customer</a:t>
-            </a:r>
-          </a:p>
-          <a:p xmlns:a="http://schemas.openxmlformats.org/drawingml/2006/main">
-            <a:pPr>
-              <a:defRPr sz="2100" b="0">
-                <a:solidFill>
-                  <a:srgbClr val="142E44"/>
-                </a:solidFill>
-                <a:latin typeface="DejaVu Sans"/>
-                <a:ea typeface="DejaVu Sans"/>
-                <a:cs typeface="DejaVu Sans"/>
-              </a:defRPr>
-            </a:pPr>
-            <a:r>
-              <a:rPr sz="2100" b="0">
-                <a:solidFill>
-                  <a:srgbClr val="142E44"/>
-                </a:solidFill>
-                <a:latin typeface="DejaVu Sans"/>
-                <a:ea typeface="DejaVu Sans"/>
-                <a:cs typeface="DejaVu Sans"/>
-              </a:rPr>
-              <a:t>surroundings and</a:t>
-            </a:r>
-          </a:p>
-          <a:p xmlns:a="http://schemas.openxmlformats.org/drawingml/2006/main">
-            <a:pPr>
-              <a:defRPr sz="2100" b="0">
-                <a:solidFill>
-                  <a:srgbClr val="142E44"/>
-                </a:solidFill>
-                <a:latin typeface="DejaVu Sans"/>
-                <a:ea typeface="DejaVu Sans"/>
-                <a:cs typeface="DejaVu Sans"/>
-              </a:defRPr>
-            </a:pPr>
-            <a:r>
-              <a:rPr sz="2100" b="0">
-                <a:solidFill>
-                  <a:srgbClr val="142E44"/>
-                </a:solidFill>
-                <a:latin typeface="DejaVu Sans"/>
-                <a:ea typeface="DejaVu Sans"/>
-                <a:cs typeface="DejaVu Sans"/>
-              </a:rPr>
-              <a:t>competitive context</a:t>
+            <a:pPr algn="l">
+              <a:buNone/>
+              <a:defRPr sz="1950" b="0">
+                <a:solidFill>
+                  <a:srgbClr val="142E44"/>
+                </a:solidFill>
+                <a:latin typeface="DejaVu Sans"/>
+                <a:ea typeface="DejaVu Sans"/>
+                <a:cs typeface="DejaVu Sans"/>
+              </a:defRPr>
+            </a:pPr>
+            <a:r>
+              <a:rPr sz="1950" b="0">
+                <a:solidFill>
+                  <a:srgbClr val="142E44"/>
+                </a:solidFill>
+                <a:latin typeface="DejaVu Sans"/>
+                <a:ea typeface="DejaVu Sans"/>
+                <a:cs typeface="DejaVu Sans"/>
+              </a:rPr>
+              <a:t>Market context and</a:t>
+            </a:r>
+          </a:p>
+          <a:p xmlns:a="http://schemas.openxmlformats.org/drawingml/2006/main">
+            <a:pPr algn="l">
+              <a:buNone/>
+              <a:defRPr sz="1950" b="0">
+                <a:solidFill>
+                  <a:srgbClr val="142E44"/>
+                </a:solidFill>
+                <a:latin typeface="DejaVu Sans"/>
+                <a:ea typeface="DejaVu Sans"/>
+                <a:cs typeface="DejaVu Sans"/>
+              </a:defRPr>
+            </a:pPr>
+            <a:r>
+              <a:rPr sz="1950" b="0">
+                <a:solidFill>
+                  <a:srgbClr val="142E44"/>
+                </a:solidFill>
+                <a:latin typeface="DejaVu Sans"/>
+                <a:ea typeface="DejaVu Sans"/>
+                <a:cs typeface="DejaVu Sans"/>
+              </a:rPr>
+              <a:t>customer surroundings</a:t>
+            </a:r>
+          </a:p>
+          <a:p xmlns:a="http://schemas.openxmlformats.org/drawingml/2006/main">
+            <a:pPr algn="l">
+              <a:buNone/>
+              <a:defRPr sz="1950" b="0">
+                <a:solidFill>
+                  <a:srgbClr val="142E44"/>
+                </a:solidFill>
+                <a:latin typeface="DejaVu Sans"/>
+                <a:ea typeface="DejaVu Sans"/>
+                <a:cs typeface="DejaVu Sans"/>
+              </a:defRPr>
+            </a:pPr>
+            <a:r>
+              <a:rPr sz="1950" b="0">
+                <a:solidFill>
+                  <a:srgbClr val="142E44"/>
+                </a:solidFill>
+                <a:latin typeface="DejaVu Sans"/>
+                <a:ea typeface="DejaVu Sans"/>
+                <a:cs typeface="DejaVu Sans"/>
+              </a:rPr>
+              <a:t>at each location</a:t>
             </a:r>
           </a:p>
         </p:txBody>
@@ -5025,6 +5056,7 @@
           <a:lstStyle xmlns:a="http://schemas.openxmlformats.org/drawingml/2006/main"/>
           <a:p xmlns:a="http://schemas.openxmlformats.org/drawingml/2006/main">
             <a:pPr>
+              <a:buNone/>
               <a:defRPr sz="2250" b="1">
                 <a:solidFill>
                   <a:srgbClr val="167AAB"/>
@@ -5082,6 +5114,7 @@
           <a:lstStyle xmlns:a="http://schemas.openxmlformats.org/drawingml/2006/main"/>
           <a:p xmlns:a="http://schemas.openxmlformats.org/drawingml/2006/main">
             <a:pPr>
+              <a:buNone/>
               <a:defRPr sz="2100" b="0">
                 <a:solidFill>
                   <a:srgbClr val="142E44"/>
@@ -5105,6 +5138,7 @@
           </a:p>
           <a:p xmlns:a="http://schemas.openxmlformats.org/drawingml/2006/main">
             <a:pPr>
+              <a:buNone/>
               <a:defRPr sz="2100" b="0">
                 <a:solidFill>
                   <a:srgbClr val="142E44"/>
@@ -5162,6 +5196,7 @@
           <a:lstStyle xmlns:a="http://schemas.openxmlformats.org/drawingml/2006/main"/>
           <a:p xmlns:a="http://schemas.openxmlformats.org/drawingml/2006/main">
             <a:pPr>
+              <a:buNone/>
               <a:defRPr sz="1725" b="0">
                 <a:solidFill>
                   <a:srgbClr val="526879"/>
@@ -5248,6 +5283,7 @@
           <a:lstStyle xmlns:a="http://schemas.openxmlformats.org/drawingml/2006/main"/>
           <a:p xmlns:a="http://schemas.openxmlformats.org/drawingml/2006/main">
             <a:pPr>
+              <a:buNone/>
               <a:defRPr sz="1350" b="1">
                 <a:solidFill>
                   <a:srgbClr val="167AAB"/>
@@ -5305,6 +5341,7 @@
           <a:lstStyle xmlns:a="http://schemas.openxmlformats.org/drawingml/2006/main"/>
           <a:p xmlns:a="http://schemas.openxmlformats.org/drawingml/2006/main">
             <a:pPr>
+              <a:buNone/>
               <a:defRPr sz="3450" b="1">
                 <a:solidFill>
                   <a:srgbClr val="142E44"/>
@@ -5362,6 +5399,7 @@
           <a:lstStyle xmlns:a="http://schemas.openxmlformats.org/drawingml/2006/main"/>
           <a:p xmlns:a="http://schemas.openxmlformats.org/drawingml/2006/main">
             <a:pPr>
+              <a:buNone/>
               <a:defRPr sz="1800" b="0">
                 <a:solidFill>
                   <a:srgbClr val="526879"/>
@@ -5419,6 +5457,7 @@
           <a:lstStyle xmlns:a="http://schemas.openxmlformats.org/drawingml/2006/main"/>
           <a:p xmlns:a="http://schemas.openxmlformats.org/drawingml/2006/main">
             <a:pPr>
+              <a:buNone/>
               <a:defRPr sz="1200" b="0">
                 <a:solidFill>
                   <a:srgbClr val="526879"/>
@@ -5476,6 +5515,7 @@
           <a:lstStyle xmlns:a="http://schemas.openxmlformats.org/drawingml/2006/main"/>
           <a:p xmlns:a="http://schemas.openxmlformats.org/drawingml/2006/main">
             <a:pPr>
+              <a:buNone/>
               <a:defRPr sz="1200" b="0">
                 <a:solidFill>
                   <a:srgbClr val="526879"/>
@@ -5501,7 +5541,7 @@
       </p:sp>
       <p:graphicFrame>
         <p:nvGraphicFramePr>
-          <p:cNvPr id="15" name="Chart"/>
+          <p:cNvPr id="17" name="Chart"/>
           <p:cNvGraphicFramePr/>
           <p:nvPr/>
         </p:nvGraphicFramePr>
@@ -5511,7 +5551,7 @@
         </p:xfrm>
         <a:graphic xmlns:a="http://schemas.openxmlformats.org/drawingml/2006/main">
           <a:graphicData uri="http://schemas.openxmlformats.org/drawingml/2006/chart">
-            <c:chart xmlns:r="http://schemas.openxmlformats.org/officeDocument/2006/relationships" xmlns:c="http://schemas.openxmlformats.org/drawingml/2006/chart" r:id="R9e8067041ffd4997"/>
+            <c:chart xmlns:r="http://schemas.openxmlformats.org/officeDocument/2006/relationships" xmlns:c="http://schemas.openxmlformats.org/drawingml/2006/chart" r:id="R19a0bb42156741b2"/>
           </a:graphicData>
         </a:graphic>
       </p:graphicFrame>
@@ -5549,6 +5589,7 @@
           <a:lstStyle xmlns:a="http://schemas.openxmlformats.org/drawingml/2006/main"/>
           <a:p xmlns:a="http://schemas.openxmlformats.org/drawingml/2006/main">
             <a:pPr>
+              <a:buNone/>
               <a:defRPr sz="2850" b="1">
                 <a:solidFill>
                   <a:srgbClr val="142E44"/>
@@ -5606,6 +5647,7 @@
           <a:lstStyle xmlns:a="http://schemas.openxmlformats.org/drawingml/2006/main"/>
           <a:p xmlns:a="http://schemas.openxmlformats.org/drawingml/2006/main">
             <a:pPr>
+              <a:buNone/>
               <a:defRPr sz="1950" b="0">
                 <a:solidFill>
                   <a:srgbClr val="142E44"/>
@@ -5629,6 +5671,7 @@
           </a:p>
           <a:p xmlns:a="http://schemas.openxmlformats.org/drawingml/2006/main">
             <a:pPr>
+              <a:buNone/>
               <a:defRPr sz="1950" b="0">
                 <a:solidFill>
                   <a:srgbClr val="142E44"/>
@@ -5652,6 +5695,7 @@
           </a:p>
           <a:p xmlns:a="http://schemas.openxmlformats.org/drawingml/2006/main">
             <a:pPr>
+              <a:buNone/>
               <a:defRPr sz="1950" b="0">
                 <a:solidFill>
                   <a:srgbClr val="142E44"/>
@@ -5709,6 +5753,7 @@
           <a:lstStyle xmlns:a="http://schemas.openxmlformats.org/drawingml/2006/main"/>
           <a:p xmlns:a="http://schemas.openxmlformats.org/drawingml/2006/main">
             <a:pPr>
+              <a:buNone/>
               <a:defRPr sz="1500" b="0">
                 <a:solidFill>
                   <a:srgbClr val="526879"/>
@@ -5795,6 +5840,7 @@
           <a:lstStyle xmlns:a="http://schemas.openxmlformats.org/drawingml/2006/main"/>
           <a:p xmlns:a="http://schemas.openxmlformats.org/drawingml/2006/main">
             <a:pPr>
+              <a:buNone/>
               <a:defRPr sz="1350" b="1">
                 <a:solidFill>
                   <a:srgbClr val="167AAB"/>
@@ -5852,6 +5898,7 @@
           <a:lstStyle xmlns:a="http://schemas.openxmlformats.org/drawingml/2006/main"/>
           <a:p xmlns:a="http://schemas.openxmlformats.org/drawingml/2006/main">
             <a:pPr>
+              <a:buNone/>
               <a:defRPr sz="3450" b="1">
                 <a:solidFill>
                   <a:srgbClr val="142E44"/>
@@ -5909,6 +5956,7 @@
           <a:lstStyle xmlns:a="http://schemas.openxmlformats.org/drawingml/2006/main"/>
           <a:p xmlns:a="http://schemas.openxmlformats.org/drawingml/2006/main">
             <a:pPr>
+              <a:buNone/>
               <a:defRPr sz="1800" b="0">
                 <a:solidFill>
                   <a:srgbClr val="526879"/>
@@ -5966,6 +6014,7 @@
           <a:lstStyle xmlns:a="http://schemas.openxmlformats.org/drawingml/2006/main"/>
           <a:p xmlns:a="http://schemas.openxmlformats.org/drawingml/2006/main">
             <a:pPr>
+              <a:buNone/>
               <a:defRPr sz="1200" b="0">
                 <a:solidFill>
                   <a:srgbClr val="526879"/>
@@ -6023,6 +6072,7 @@
           <a:lstStyle xmlns:a="http://schemas.openxmlformats.org/drawingml/2006/main"/>
           <a:p xmlns:a="http://schemas.openxmlformats.org/drawingml/2006/main">
             <a:pPr>
+              <a:buNone/>
               <a:defRPr sz="1200" b="0">
                 <a:solidFill>
                   <a:srgbClr val="526879"/>
@@ -6048,7 +6098,7 @@
       </p:sp>
       <p:graphicFrame>
         <p:nvGraphicFramePr>
-          <p:cNvPr id="17" name="Chart"/>
+          <p:cNvPr id="19" name="Chart"/>
           <p:cNvGraphicFramePr/>
           <p:nvPr/>
         </p:nvGraphicFramePr>
@@ -6058,7 +6108,7 @@
         </p:xfrm>
         <a:graphic xmlns:a="http://schemas.openxmlformats.org/drawingml/2006/main">
           <a:graphicData uri="http://schemas.openxmlformats.org/drawingml/2006/chart">
-            <c:chart xmlns:r="http://schemas.openxmlformats.org/officeDocument/2006/relationships" xmlns:c="http://schemas.openxmlformats.org/drawingml/2006/chart" r:id="Ra4865557b81f4031"/>
+            <c:chart xmlns:r="http://schemas.openxmlformats.org/officeDocument/2006/relationships" xmlns:c="http://schemas.openxmlformats.org/drawingml/2006/chart" r:id="R5f6dccf222724a07"/>
           </a:graphicData>
         </a:graphic>
       </p:graphicFrame>
@@ -6096,6 +6146,7 @@
           <a:lstStyle xmlns:a="http://schemas.openxmlformats.org/drawingml/2006/main"/>
           <a:p xmlns:a="http://schemas.openxmlformats.org/drawingml/2006/main">
             <a:pPr>
+              <a:buNone/>
               <a:defRPr sz="1500" b="0">
                 <a:solidFill>
                   <a:srgbClr val="526879"/>
@@ -6153,6 +6204,7 @@
           <a:lstStyle xmlns:a="http://schemas.openxmlformats.org/drawingml/2006/main"/>
           <a:p xmlns:a="http://schemas.openxmlformats.org/drawingml/2006/main">
             <a:pPr>
+              <a:buNone/>
               <a:defRPr sz="2175" b="1">
                 <a:solidFill>
                   <a:srgbClr val="167AAB"/>
@@ -6209,7 +6261,8 @@
           </a:bodyPr>
           <a:lstStyle xmlns:a="http://schemas.openxmlformats.org/drawingml/2006/main"/>
           <a:p xmlns:a="http://schemas.openxmlformats.org/drawingml/2006/main">
-            <a:pPr>
+            <a:pPr algn="l">
+              <a:buNone/>
               <a:defRPr sz="1800" b="0">
                 <a:solidFill>
                   <a:srgbClr val="142E44"/>
@@ -6228,11 +6281,12 @@
                 <a:ea typeface="DejaVu Sans"/>
                 <a:cs typeface="DejaVu Sans"/>
               </a:rPr>
-              <a:t>Adjustable scenario weights</a:t>
-            </a:r>
-          </a:p>
-          <a:p xmlns:a="http://schemas.openxmlformats.org/drawingml/2006/main">
-            <a:pPr>
+              <a:t>Density: up to +5 points</a:t>
+            </a:r>
+          </a:p>
+          <a:p xmlns:a="http://schemas.openxmlformats.org/drawingml/2006/main">
+            <a:pPr algn="l">
+              <a:buNone/>
               <a:defRPr sz="1800" b="0">
                 <a:solidFill>
                   <a:srgbClr val="142E44"/>
@@ -6251,11 +6305,12 @@
                 <a:ea typeface="DejaVu Sans"/>
                 <a:cs typeface="DejaVu Sans"/>
               </a:rPr>
-              <a:t>Competition penalties</a:t>
-            </a:r>
-          </a:p>
-          <a:p xmlns:a="http://schemas.openxmlformats.org/drawingml/2006/main">
-            <a:pPr>
+              <a:t>Competition: up to −5</a:t>
+            </a:r>
+          </a:p>
+          <a:p xmlns:a="http://schemas.openxmlformats.org/drawingml/2006/main">
+            <a:pPr algn="l">
+              <a:buNone/>
               <a:defRPr sz="1800" b="0">
                 <a:solidFill>
                   <a:srgbClr val="142E44"/>
@@ -6274,7 +6329,7 @@
                 <a:ea typeface="DejaVu Sans"/>
                 <a:cs typeface="DejaVu Sans"/>
               </a:rPr>
-              <a:t>Inspectable contributions</a:t>
+              <a:t>Mutually exclusive effects</a:t>
             </a:r>
           </a:p>
         </p:txBody>
@@ -6313,6 +6368,7 @@
           <a:lstStyle xmlns:a="http://schemas.openxmlformats.org/drawingml/2006/main"/>
           <a:p xmlns:a="http://schemas.openxmlformats.org/drawingml/2006/main">
             <a:pPr>
+              <a:buNone/>
               <a:defRPr sz="2175" b="1">
                 <a:solidFill>
                   <a:srgbClr val="167AAB"/>
@@ -6370,6 +6426,7 @@
           <a:lstStyle xmlns:a="http://schemas.openxmlformats.org/drawingml/2006/main"/>
           <a:p xmlns:a="http://schemas.openxmlformats.org/drawingml/2006/main">
             <a:pPr>
+              <a:buNone/>
               <a:defRPr sz="1725" b="0">
                 <a:solidFill>
                   <a:srgbClr val="526879"/>
@@ -6393,6 +6450,7 @@
           </a:p>
           <a:p xmlns:a="http://schemas.openxmlformats.org/drawingml/2006/main">
             <a:pPr>
+              <a:buNone/>
               <a:defRPr sz="1725" b="0">
                 <a:solidFill>
                   <a:srgbClr val="526879"/>
@@ -6479,6 +6537,7 @@
           <a:lstStyle xmlns:a="http://schemas.openxmlformats.org/drawingml/2006/main"/>
           <a:p xmlns:a="http://schemas.openxmlformats.org/drawingml/2006/main">
             <a:pPr>
+              <a:buNone/>
               <a:defRPr sz="1350" b="1">
                 <a:solidFill>
                   <a:srgbClr val="167AAB"/>
@@ -6536,6 +6595,7 @@
           <a:lstStyle xmlns:a="http://schemas.openxmlformats.org/drawingml/2006/main"/>
           <a:p xmlns:a="http://schemas.openxmlformats.org/drawingml/2006/main">
             <a:pPr>
+              <a:buNone/>
               <a:defRPr sz="3450" b="1">
                 <a:solidFill>
                   <a:srgbClr val="142E44"/>
@@ -6593,6 +6653,7 @@
           <a:lstStyle xmlns:a="http://schemas.openxmlformats.org/drawingml/2006/main"/>
           <a:p xmlns:a="http://schemas.openxmlformats.org/drawingml/2006/main">
             <a:pPr>
+              <a:buNone/>
               <a:defRPr sz="1800" b="0">
                 <a:solidFill>
                   <a:srgbClr val="526879"/>
@@ -6650,6 +6711,7 @@
           <a:lstStyle xmlns:a="http://schemas.openxmlformats.org/drawingml/2006/main"/>
           <a:p xmlns:a="http://schemas.openxmlformats.org/drawingml/2006/main">
             <a:pPr>
+              <a:buNone/>
               <a:defRPr sz="1200" b="0">
                 <a:solidFill>
                   <a:srgbClr val="526879"/>
@@ -6707,6 +6769,7 @@
           <a:lstStyle xmlns:a="http://schemas.openxmlformats.org/drawingml/2006/main"/>
           <a:p xmlns:a="http://schemas.openxmlformats.org/drawingml/2006/main">
             <a:pPr>
+              <a:buNone/>
               <a:defRPr sz="1200" b="0">
                 <a:solidFill>
                   <a:srgbClr val="526879"/>
@@ -6732,7 +6795,7 @@
       </p:sp>
       <p:graphicFrame>
         <p:nvGraphicFramePr>
-          <p:cNvPr id="15" name="Chart"/>
+          <p:cNvPr id="17" name="Chart"/>
           <p:cNvGraphicFramePr/>
           <p:nvPr/>
         </p:nvGraphicFramePr>
@@ -6742,7 +6805,7 @@
         </p:xfrm>
         <a:graphic xmlns:a="http://schemas.openxmlformats.org/drawingml/2006/main">
           <a:graphicData uri="http://schemas.openxmlformats.org/drawingml/2006/chart">
-            <c:chart xmlns:r="http://schemas.openxmlformats.org/officeDocument/2006/relationships" xmlns:c="http://schemas.openxmlformats.org/drawingml/2006/chart" r:id="R3413bc2ff46643ea"/>
+            <c:chart xmlns:r="http://schemas.openxmlformats.org/officeDocument/2006/relationships" xmlns:c="http://schemas.openxmlformats.org/drawingml/2006/chart" r:id="R99c9e22a04c14e3a"/>
           </a:graphicData>
         </a:graphic>
       </p:graphicFrame>
@@ -6780,6 +6843,7 @@
           <a:lstStyle xmlns:a="http://schemas.openxmlformats.org/drawingml/2006/main"/>
           <a:p xmlns:a="http://schemas.openxmlformats.org/drawingml/2006/main">
             <a:pPr>
+              <a:buNone/>
               <a:defRPr sz="4800" b="1">
                 <a:solidFill>
                   <a:srgbClr val="142E44"/>
@@ -6837,6 +6901,7 @@
           <a:lstStyle xmlns:a="http://schemas.openxmlformats.org/drawingml/2006/main"/>
           <a:p xmlns:a="http://schemas.openxmlformats.org/drawingml/2006/main">
             <a:pPr>
+              <a:buNone/>
               <a:defRPr sz="1800" b="0">
                 <a:solidFill>
                   <a:srgbClr val="142E44"/>
@@ -6860,6 +6925,7 @@
           </a:p>
           <a:p xmlns:a="http://schemas.openxmlformats.org/drawingml/2006/main">
             <a:pPr>
+              <a:buNone/>
               <a:defRPr sz="1800" b="0">
                 <a:solidFill>
                   <a:srgbClr val="142E44"/>
@@ -6917,6 +6983,7 @@
           <a:lstStyle xmlns:a="http://schemas.openxmlformats.org/drawingml/2006/main"/>
           <a:p xmlns:a="http://schemas.openxmlformats.org/drawingml/2006/main">
             <a:pPr>
+              <a:buNone/>
               <a:defRPr sz="1575" b="0">
                 <a:solidFill>
                   <a:srgbClr val="526879"/>
@@ -7003,6 +7070,7 @@
           <a:lstStyle xmlns:a="http://schemas.openxmlformats.org/drawingml/2006/main"/>
           <a:p xmlns:a="http://schemas.openxmlformats.org/drawingml/2006/main">
             <a:pPr>
+              <a:buNone/>
               <a:defRPr sz="1350" b="1">
                 <a:solidFill>
                   <a:srgbClr val="167AAB"/>
@@ -7060,6 +7128,7 @@
           <a:lstStyle xmlns:a="http://schemas.openxmlformats.org/drawingml/2006/main"/>
           <a:p xmlns:a="http://schemas.openxmlformats.org/drawingml/2006/main">
             <a:pPr>
+              <a:buNone/>
               <a:defRPr sz="3450" b="1">
                 <a:solidFill>
                   <a:srgbClr val="142E44"/>
@@ -7117,6 +7186,7 @@
           <a:lstStyle xmlns:a="http://schemas.openxmlformats.org/drawingml/2006/main"/>
           <a:p xmlns:a="http://schemas.openxmlformats.org/drawingml/2006/main">
             <a:pPr>
+              <a:buNone/>
               <a:defRPr sz="1800" b="0">
                 <a:solidFill>
                   <a:srgbClr val="526879"/>
@@ -7174,6 +7244,7 @@
           <a:lstStyle xmlns:a="http://schemas.openxmlformats.org/drawingml/2006/main"/>
           <a:p xmlns:a="http://schemas.openxmlformats.org/drawingml/2006/main">
             <a:pPr>
+              <a:buNone/>
               <a:defRPr sz="1200" b="0">
                 <a:solidFill>
                   <a:srgbClr val="526879"/>
@@ -7231,6 +7302,7 @@
           <a:lstStyle xmlns:a="http://schemas.openxmlformats.org/drawingml/2006/main"/>
           <a:p xmlns:a="http://schemas.openxmlformats.org/drawingml/2006/main">
             <a:pPr>
+              <a:buNone/>
               <a:defRPr sz="1200" b="0">
                 <a:solidFill>
                   <a:srgbClr val="526879"/>
@@ -7256,14 +7328,14 @@
       </p:sp>
       <p:pic>
         <p:nvPicPr>
-          <p:cNvPr id="17" name=""/>
+          <p:cNvPr id="19" name=""/>
           <p:cNvPicPr>
             <a:picLocks xmlns:a="http://schemas.openxmlformats.org/drawingml/2006/main" noChangeAspect="1"/>
           </p:cNvPicPr>
           <p:nvPr/>
         </p:nvPicPr>
         <p:blipFill>
-          <a:blip xmlns:r="http://schemas.openxmlformats.org/officeDocument/2006/relationships" xmlns:a="http://schemas.openxmlformats.org/drawingml/2006/main" r:embed="R7facee4f4ed6465b"/>
+          <a:blip xmlns:r="http://schemas.openxmlformats.org/officeDocument/2006/relationships" xmlns:a="http://schemas.openxmlformats.org/drawingml/2006/main" r:embed="R6f2eaff3e5294bf5"/>
           <a:stretch xmlns:a="http://schemas.openxmlformats.org/drawingml/2006/main"/>
         </p:blipFill>
         <p:spPr>
@@ -7310,6 +7382,7 @@
           <a:lstStyle xmlns:a="http://schemas.openxmlformats.org/drawingml/2006/main"/>
           <a:p xmlns:a="http://schemas.openxmlformats.org/drawingml/2006/main">
             <a:pPr>
+              <a:buNone/>
               <a:defRPr sz="2175" b="1">
                 <a:solidFill>
                   <a:srgbClr val="142E44"/>
@@ -7367,6 +7440,7 @@
           <a:lstStyle xmlns:a="http://schemas.openxmlformats.org/drawingml/2006/main"/>
           <a:p xmlns:a="http://schemas.openxmlformats.org/drawingml/2006/main">
             <a:pPr>
+              <a:buNone/>
               <a:defRPr sz="2175" b="1">
                 <a:solidFill>
                   <a:srgbClr val="142E44"/>
@@ -7424,6 +7498,7 @@
           <a:lstStyle xmlns:a="http://schemas.openxmlformats.org/drawingml/2006/main"/>
           <a:p xmlns:a="http://schemas.openxmlformats.org/drawingml/2006/main">
             <a:pPr>
+              <a:buNone/>
               <a:defRPr sz="2175" b="1">
                 <a:solidFill>
                   <a:srgbClr val="142E44"/>
@@ -7481,6 +7556,7 @@
           <a:lstStyle xmlns:a="http://schemas.openxmlformats.org/drawingml/2006/main"/>
           <a:p xmlns:a="http://schemas.openxmlformats.org/drawingml/2006/main">
             <a:pPr>
+              <a:buNone/>
               <a:defRPr sz="2025" b="1">
                 <a:solidFill>
                   <a:srgbClr val="142E44"/>
@@ -7538,6 +7614,7 @@
           <a:lstStyle xmlns:a="http://schemas.openxmlformats.org/drawingml/2006/main"/>
           <a:p xmlns:a="http://schemas.openxmlformats.org/drawingml/2006/main">
             <a:pPr>
+              <a:buNone/>
               <a:defRPr sz="1350" b="0">
                 <a:solidFill>
                   <a:srgbClr val="526879"/>
@@ -7624,6 +7701,7 @@
           <a:lstStyle xmlns:a="http://schemas.openxmlformats.org/drawingml/2006/main"/>
           <a:p xmlns:a="http://schemas.openxmlformats.org/drawingml/2006/main">
             <a:pPr>
+              <a:buNone/>
               <a:defRPr sz="1350" b="1">
                 <a:solidFill>
                   <a:srgbClr val="167AAB"/>
@@ -7681,6 +7759,7 @@
           <a:lstStyle xmlns:a="http://schemas.openxmlformats.org/drawingml/2006/main"/>
           <a:p xmlns:a="http://schemas.openxmlformats.org/drawingml/2006/main">
             <a:pPr>
+              <a:buNone/>
               <a:defRPr sz="3450" b="1">
                 <a:solidFill>
                   <a:srgbClr val="142E44"/>
@@ -7738,6 +7817,7 @@
           <a:lstStyle xmlns:a="http://schemas.openxmlformats.org/drawingml/2006/main"/>
           <a:p xmlns:a="http://schemas.openxmlformats.org/drawingml/2006/main">
             <a:pPr>
+              <a:buNone/>
               <a:defRPr sz="1800" b="0">
                 <a:solidFill>
                   <a:srgbClr val="526879"/>
@@ -7795,6 +7875,7 @@
           <a:lstStyle xmlns:a="http://schemas.openxmlformats.org/drawingml/2006/main"/>
           <a:p xmlns:a="http://schemas.openxmlformats.org/drawingml/2006/main">
             <a:pPr>
+              <a:buNone/>
               <a:defRPr sz="1200" b="0">
                 <a:solidFill>
                   <a:srgbClr val="526879"/>
@@ -7852,6 +7933,7 @@
           <a:lstStyle xmlns:a="http://schemas.openxmlformats.org/drawingml/2006/main"/>
           <a:p xmlns:a="http://schemas.openxmlformats.org/drawingml/2006/main">
             <a:pPr>
+              <a:buNone/>
               <a:defRPr sz="1200" b="0">
                 <a:solidFill>
                   <a:srgbClr val="526879"/>
@@ -7909,6 +7991,7 @@
           <a:lstStyle xmlns:a="http://schemas.openxmlformats.org/drawingml/2006/main"/>
           <a:p xmlns:a="http://schemas.openxmlformats.org/drawingml/2006/main">
             <a:pPr>
+              <a:buNone/>
               <a:defRPr sz="2250" b="1">
                 <a:solidFill>
                   <a:srgbClr val="167AAB"/>
@@ -7965,7 +8048,8 @@
           </a:bodyPr>
           <a:lstStyle xmlns:a="http://schemas.openxmlformats.org/drawingml/2006/main"/>
           <a:p xmlns:a="http://schemas.openxmlformats.org/drawingml/2006/main">
-            <a:pPr>
+            <a:pPr algn="l">
+              <a:buNone/>
               <a:defRPr sz="1875" b="0">
                 <a:solidFill>
                   <a:srgbClr val="142E44"/>
@@ -7984,11 +8068,12 @@
                 <a:ea typeface="DejaVu Sans"/>
                 <a:cs typeface="DejaVu Sans"/>
               </a:rPr>
-              <a:t>43 tests passed on Python 3.11 / 3.12</a:t>
-            </a:r>
-          </a:p>
-          <a:p xmlns:a="http://schemas.openxmlformats.org/drawingml/2006/main">
-            <a:pPr>
+              <a:t>Updated scoring and UI flows</a:t>
+            </a:r>
+          </a:p>
+          <a:p xmlns:a="http://schemas.openxmlformats.org/drawingml/2006/main">
+            <a:pPr algn="l">
+              <a:buNone/>
               <a:defRPr sz="1875" b="0">
                 <a:solidFill>
                   <a:srgbClr val="142E44"/>
@@ -8007,11 +8092,12 @@
                 <a:ea typeface="DejaVu Sans"/>
                 <a:cs typeface="DejaVu Sans"/>
               </a:rPr>
-              <a:t>Scoring, held-out evaluation and UI flows</a:t>
-            </a:r>
-          </a:p>
-          <a:p xmlns:a="http://schemas.openxmlformats.org/drawingml/2006/main">
-            <a:pPr>
+              <a:t>Conditional density bonus</a:t>
+            </a:r>
+          </a:p>
+          <a:p xmlns:a="http://schemas.openxmlformats.org/drawingml/2006/main">
+            <a:pPr algn="l">
+              <a:buNone/>
               <a:defRPr sz="1875" b="0">
                 <a:solidFill>
                   <a:srgbClr val="142E44"/>
@@ -8030,7 +8116,7 @@
                 <a:ea typeface="DejaVu Sans"/>
                 <a:cs typeface="DejaVu Sans"/>
               </a:rPr>
-              <a:t>No algorithm change in this update</a:t>
+              <a:t>47 tests passed locally</a:t>
             </a:r>
           </a:p>
         </p:txBody>
@@ -8069,6 +8155,7 @@
           <a:lstStyle xmlns:a="http://schemas.openxmlformats.org/drawingml/2006/main"/>
           <a:p xmlns:a="http://schemas.openxmlformats.org/drawingml/2006/main">
             <a:pPr>
+              <a:buNone/>
               <a:defRPr sz="2250" b="1">
                 <a:solidFill>
                   <a:srgbClr val="167AAB"/>
@@ -8126,6 +8213,7 @@
           <a:lstStyle xmlns:a="http://schemas.openxmlformats.org/drawingml/2006/main"/>
           <a:p xmlns:a="http://schemas.openxmlformats.org/drawingml/2006/main">
             <a:pPr>
+              <a:buNone/>
               <a:defRPr sz="1875" b="0">
                 <a:solidFill>
                   <a:srgbClr val="142E44"/>
@@ -8149,6 +8237,7 @@
           </a:p>
           <a:p xmlns:a="http://schemas.openxmlformats.org/drawingml/2006/main">
             <a:pPr>
+              <a:buNone/>
               <a:defRPr sz="1875" b="0">
                 <a:solidFill>
                   <a:srgbClr val="142E44"/>
@@ -8172,6 +8261,7 @@
           </a:p>
           <a:p xmlns:a="http://schemas.openxmlformats.org/drawingml/2006/main">
             <a:pPr>
+              <a:buNone/>
               <a:defRPr sz="1875" b="0">
                 <a:solidFill>
                   <a:srgbClr val="142E44"/>
@@ -8228,7 +8318,8 @@
           </a:bodyPr>
           <a:lstStyle xmlns:a="http://schemas.openxmlformats.org/drawingml/2006/main"/>
           <a:p xmlns:a="http://schemas.openxmlformats.org/drawingml/2006/main">
-            <a:pPr>
+            <a:pPr algn="l">
+              <a:buNone/>
               <a:defRPr sz="1500" b="0">
                 <a:solidFill>
                   <a:srgbClr val="526879"/>
@@ -8247,7 +8338,7 @@
                 <a:ea typeface="DejaVu Sans"/>
                 <a:cs typeface="DejaVu Sans"/>
               </a:rPr>
-              <a:t>Technical baseline: main 58ce550. Latest documentation checks are separate.</a:t>
+              <a:t>Next validation: compare shortlist time and quality in a user pilot.</a:t>
             </a:r>
           </a:p>
         </p:txBody>
@@ -8315,6 +8406,7 @@
           <a:lstStyle xmlns:a="http://schemas.openxmlformats.org/drawingml/2006/main"/>
           <a:p xmlns:a="http://schemas.openxmlformats.org/drawingml/2006/main">
             <a:pPr>
+              <a:buNone/>
               <a:defRPr sz="1350" b="1">
                 <a:solidFill>
                   <a:srgbClr val="167AAB"/>
@@ -8371,26 +8463,27 @@
           </a:bodyPr>
           <a:lstStyle xmlns:a="http://schemas.openxmlformats.org/drawingml/2006/main"/>
           <a:p xmlns:a="http://schemas.openxmlformats.org/drawingml/2006/main">
-            <a:pPr>
-              <a:defRPr sz="3450" b="1">
-                <a:solidFill>
-                  <a:srgbClr val="142E44"/>
-                </a:solidFill>
-                <a:latin typeface="DejaVu Sans"/>
-                <a:ea typeface="DejaVu Sans"/>
-                <a:cs typeface="DejaVu Sans"/>
-              </a:defRPr>
-            </a:pPr>
-            <a:r>
-              <a:rPr sz="3450" b="1">
-                <a:solidFill>
-                  <a:srgbClr val="142E44"/>
-                </a:solidFill>
-                <a:latin typeface="DejaVu Sans"/>
-                <a:ea typeface="DejaVu Sans"/>
-                <a:cs typeface="DejaVu Sans"/>
-              </a:rPr>
-              <a:t>The next proof is a timed user pilot</a:t>
+            <a:pPr algn="l">
+              <a:buNone/>
+              <a:defRPr sz="3000" b="1">
+                <a:solidFill>
+                  <a:srgbClr val="142E44"/>
+                </a:solidFill>
+                <a:latin typeface="DejaVu Sans"/>
+                <a:ea typeface="DejaVu Sans"/>
+                <a:cs typeface="DejaVu Sans"/>
+              </a:defRPr>
+            </a:pPr>
+            <a:r>
+              <a:rPr sz="3000" b="1">
+                <a:solidFill>
+                  <a:srgbClr val="142E44"/>
+                </a:solidFill>
+                <a:latin typeface="DejaVu Sans"/>
+                <a:ea typeface="DejaVu Sans"/>
+                <a:cs typeface="DejaVu Sans"/>
+              </a:rPr>
+              <a:t>Connection to UN Sustainable Development Goals</a:t>
             </a:r>
           </a:p>
         </p:txBody>
@@ -8428,7 +8521,8 @@
           </a:bodyPr>
           <a:lstStyle xmlns:a="http://schemas.openxmlformats.org/drawingml/2006/main"/>
           <a:p xmlns:a="http://schemas.openxmlformats.org/drawingml/2006/main">
-            <a:pPr>
+            <a:pPr algn="l">
+              <a:buNone/>
               <a:defRPr sz="1800" b="0">
                 <a:solidFill>
                   <a:srgbClr val="526879"/>
@@ -8447,7 +8541,7 @@
                 <a:ea typeface="DejaVu Sans"/>
                 <a:cs typeface="DejaVu Sans"/>
               </a:rPr>
-              <a:t>Aim: help entrepreneurs prepare a useful shortlist faster.</a:t>
+              <a:t>Design intentions. Sustainability outcomes still need measurement.</a:t>
             </a:r>
           </a:p>
         </p:txBody>
@@ -8486,6 +8580,7 @@
           <a:lstStyle xmlns:a="http://schemas.openxmlformats.org/drawingml/2006/main"/>
           <a:p xmlns:a="http://schemas.openxmlformats.org/drawingml/2006/main">
             <a:pPr>
+              <a:buNone/>
               <a:defRPr sz="1200" b="0">
                 <a:solidFill>
                   <a:srgbClr val="526879"/>
@@ -8543,6 +8638,7 @@
           <a:lstStyle xmlns:a="http://schemas.openxmlformats.org/drawingml/2006/main"/>
           <a:p xmlns:a="http://schemas.openxmlformats.org/drawingml/2006/main">
             <a:pPr>
+              <a:buNone/>
               <a:defRPr sz="1200" b="0">
                 <a:solidFill>
                   <a:srgbClr val="526879"/>
@@ -8599,7 +8695,8 @@
           </a:bodyPr>
           <a:lstStyle xmlns:a="http://schemas.openxmlformats.org/drawingml/2006/main"/>
           <a:p xmlns:a="http://schemas.openxmlformats.org/drawingml/2006/main">
-            <a:pPr>
+            <a:pPr algn="l">
+              <a:buNone/>
               <a:defRPr sz="2250" b="1">
                 <a:solidFill>
                   <a:srgbClr val="167AAB"/>
@@ -8618,7 +8715,7 @@
                 <a:ea typeface="DejaVu Sans"/>
                 <a:cs typeface="DejaVu Sans"/>
               </a:rPr>
-              <a:t>Compare the same task</a:t>
+              <a:t>SDG 3 and SDG 8</a:t>
             </a:r>
           </a:p>
         </p:txBody>
@@ -8656,7 +8753,56 @@
           </a:bodyPr>
           <a:lstStyle xmlns:a="http://schemas.openxmlformats.org/drawingml/2006/main"/>
           <a:p xmlns:a="http://schemas.openxmlformats.org/drawingml/2006/main">
+            <a:pPr algn="l">
+              <a:buNone/>
+              <a:defRPr sz="1650" b="0">
+                <a:solidFill>
+                  <a:srgbClr val="142E44"/>
+                </a:solidFill>
+                <a:latin typeface="DejaVu Sans"/>
+                <a:ea typeface="DejaVu Sans"/>
+                <a:cs typeface="DejaVu Sans"/>
+              </a:defRPr>
+            </a:pPr>
+            <a:r>
+              <a:rPr sz="1650" b="0">
+                <a:solidFill>
+                  <a:srgbClr val="142E44"/>
+                </a:solidFill>
+                <a:latin typeface="DejaVu Sans"/>
+                <a:ea typeface="DejaVu Sans"/>
+                <a:cs typeface="DejaVu Sans"/>
+              </a:rPr>
+              <a:t>3  Good Health and Well-being</a:t>
+            </a:r>
+          </a:p>
+          <a:p xmlns:a="http://schemas.openxmlformats.org/drawingml/2006/main">
+            <a:pPr algn="l">
+              <a:buNone/>
+              <a:defRPr sz="1650" b="0">
+                <a:solidFill>
+                  <a:srgbClr val="142E44"/>
+                </a:solidFill>
+                <a:latin typeface="DejaVu Sans"/>
+                <a:ea typeface="DejaVu Sans"/>
+                <a:cs typeface="DejaVu Sans"/>
+              </a:defRPr>
+            </a:pPr>
+            <a:r>
+              <a:rPr sz="1650" b="0">
+                <a:solidFill>
+                  <a:srgbClr val="142E44"/>
+                </a:solidFill>
+                <a:latin typeface="DejaVu Sans"/>
+                <a:ea typeface="DejaVu Sans"/>
+                <a:cs typeface="DejaVu Sans"/>
+              </a:rPr>
+              <a:t>Accessible social places near parks</a:t>
+            </a:r>
+          </a:p>
+          <a:p xmlns:a="http://schemas.openxmlformats.org/drawingml/2006/main">
             <a:pPr>
+              <a:buNone/>
               <a:defRPr sz="2025" b="0">
                 <a:solidFill>
                   <a:srgbClr val="142E44"/>
@@ -8675,53 +8821,55 @@
                 <a:ea typeface="DejaVu Sans"/>
                 <a:cs typeface="DejaVu Sans"/>
               </a:rPr>
-              <a:t>Manual map workflow vs. dashboard</a:t>
-            </a:r>
-          </a:p>
-          <a:p xmlns:a="http://schemas.openxmlformats.org/drawingml/2006/main">
-            <a:pPr>
-              <a:defRPr sz="2025" b="0">
-                <a:solidFill>
-                  <a:srgbClr val="142E44"/>
-                </a:solidFill>
-                <a:latin typeface="DejaVu Sans"/>
-                <a:ea typeface="DejaVu Sans"/>
-                <a:cs typeface="DejaVu Sans"/>
-              </a:defRPr>
-            </a:pPr>
-            <a:r>
-              <a:rPr sz="2025" b="0">
-                <a:solidFill>
-                  <a:srgbClr val="142E44"/>
-                </a:solidFill>
-                <a:latin typeface="DejaVu Sans"/>
-                <a:ea typeface="DejaVu Sans"/>
-                <a:cs typeface="DejaVu Sans"/>
-              </a:rPr>
-              <a:t>Measure median completion time</a:t>
-            </a:r>
-          </a:p>
-          <a:p xmlns:a="http://schemas.openxmlformats.org/drawingml/2006/main">
-            <a:pPr>
-              <a:defRPr sz="2025" b="0">
-                <a:solidFill>
-                  <a:srgbClr val="142E44"/>
-                </a:solidFill>
-                <a:latin typeface="DejaVu Sans"/>
-                <a:ea typeface="DejaVu Sans"/>
-                <a:cs typeface="DejaVu Sans"/>
-              </a:defRPr>
-            </a:pPr>
-            <a:r>
-              <a:rPr sz="2025" b="0">
-                <a:solidFill>
-                  <a:srgbClr val="142E44"/>
-                </a:solidFill>
-                <a:latin typeface="DejaVu Sans"/>
-                <a:ea typeface="DejaVu Sans"/>
-                <a:cs typeface="DejaVu Sans"/>
-              </a:rPr>
-              <a:t>Review shortlist quality</a:t>
+              <a:t/>
+            </a:r>
+          </a:p>
+          <a:p xmlns:a="http://schemas.openxmlformats.org/drawingml/2006/main">
+            <a:pPr algn="l">
+              <a:buNone/>
+              <a:defRPr sz="1650" b="0">
+                <a:solidFill>
+                  <a:srgbClr val="142E44"/>
+                </a:solidFill>
+                <a:latin typeface="DejaVu Sans"/>
+                <a:ea typeface="DejaVu Sans"/>
+                <a:cs typeface="DejaVu Sans"/>
+              </a:defRPr>
+            </a:pPr>
+            <a:r>
+              <a:rPr sz="1650" b="0">
+                <a:solidFill>
+                  <a:srgbClr val="142E44"/>
+                </a:solidFill>
+                <a:latin typeface="DejaVu Sans"/>
+                <a:ea typeface="DejaVu Sans"/>
+                <a:cs typeface="DejaVu Sans"/>
+              </a:rPr>
+              <a:t>8  Decent Work and Economic Growth</a:t>
+            </a:r>
+          </a:p>
+          <a:p xmlns:a="http://schemas.openxmlformats.org/drawingml/2006/main">
+            <a:pPr algn="l">
+              <a:buNone/>
+              <a:defRPr sz="1650" b="0">
+                <a:solidFill>
+                  <a:srgbClr val="142E44"/>
+                </a:solidFill>
+                <a:latin typeface="DejaVu Sans"/>
+                <a:ea typeface="DejaVu Sans"/>
+                <a:cs typeface="DejaVu Sans"/>
+              </a:defRPr>
+            </a:pPr>
+            <a:r>
+              <a:rPr sz="1650" b="0">
+                <a:solidFill>
+                  <a:srgbClr val="142E44"/>
+                </a:solidFill>
+                <a:latin typeface="DejaVu Sans"/>
+                <a:ea typeface="DejaVu Sans"/>
+                <a:cs typeface="DejaVu Sans"/>
+              </a:rPr>
+              <a:t>Better-informed local business planning</a:t>
             </a:r>
           </a:p>
         </p:txBody>
@@ -8759,7 +8907,8 @@
           </a:bodyPr>
           <a:lstStyle xmlns:a="http://schemas.openxmlformats.org/drawingml/2006/main"/>
           <a:p xmlns:a="http://schemas.openxmlformats.org/drawingml/2006/main">
-            <a:pPr>
+            <a:pPr algn="l">
+              <a:buNone/>
               <a:defRPr sz="2250" b="1">
                 <a:solidFill>
                   <a:srgbClr val="167AAB"/>
@@ -8778,7 +8927,7 @@
                 <a:ea typeface="DejaVu Sans"/>
                 <a:cs typeface="DejaVu Sans"/>
               </a:rPr>
-              <a:t>Improve the evidence</a:t>
+              <a:t>SDG 11</a:t>
             </a:r>
           </a:p>
         </p:txBody>
@@ -8816,7 +8965,80 @@
           </a:bodyPr>
           <a:lstStyle xmlns:a="http://schemas.openxmlformats.org/drawingml/2006/main"/>
           <a:p xmlns:a="http://schemas.openxmlformats.org/drawingml/2006/main">
+            <a:pPr algn="l">
+              <a:buNone/>
+              <a:defRPr sz="1650" b="0">
+                <a:solidFill>
+                  <a:srgbClr val="142E44"/>
+                </a:solidFill>
+                <a:latin typeface="DejaVu Sans"/>
+                <a:ea typeface="DejaVu Sans"/>
+                <a:cs typeface="DejaVu Sans"/>
+              </a:defRPr>
+            </a:pPr>
+            <a:r>
+              <a:rPr sz="1650" b="0">
+                <a:solidFill>
+                  <a:srgbClr val="142E44"/>
+                </a:solidFill>
+                <a:latin typeface="DejaVu Sans"/>
+                <a:ea typeface="DejaVu Sans"/>
+                <a:cs typeface="DejaVu Sans"/>
+              </a:rPr>
+              <a:t>Sustainable Cities and Communities</a:t>
+            </a:r>
+          </a:p>
+          <a:p xmlns:a="http://schemas.openxmlformats.org/drawingml/2006/main">
+            <a:pPr algn="l">
+              <a:buNone/>
+              <a:defRPr sz="1650" b="0">
+                <a:solidFill>
+                  <a:srgbClr val="142E44"/>
+                </a:solidFill>
+                <a:latin typeface="DejaVu Sans"/>
+                <a:ea typeface="DejaVu Sans"/>
+                <a:cs typeface="DejaVu Sans"/>
+              </a:defRPr>
+            </a:pPr>
+            <a:r>
+              <a:rPr sz="1650" b="0">
+                <a:solidFill>
+                  <a:srgbClr val="142E44"/>
+                </a:solidFill>
+                <a:latin typeface="DejaVu Sans"/>
+                <a:ea typeface="DejaVu Sans"/>
+                <a:cs typeface="DejaVu Sans"/>
+              </a:rPr>
+              <a:t>Consider public transport, parks</a:t>
+            </a:r>
+          </a:p>
+          <a:p xmlns:a="http://schemas.openxmlformats.org/drawingml/2006/main">
+            <a:pPr algn="l">
+              <a:buNone/>
+              <a:defRPr sz="1650" b="0">
+                <a:solidFill>
+                  <a:srgbClr val="142E44"/>
+                </a:solidFill>
+                <a:latin typeface="DejaVu Sans"/>
+                <a:ea typeface="DejaVu Sans"/>
+                <a:cs typeface="DejaVu Sans"/>
+              </a:defRPr>
+            </a:pPr>
+            <a:r>
+              <a:rPr sz="1650" b="0">
+                <a:solidFill>
+                  <a:srgbClr val="142E44"/>
+                </a:solidFill>
+                <a:latin typeface="DejaVu Sans"/>
+                <a:ea typeface="DejaVu Sans"/>
+                <a:cs typeface="DejaVu Sans"/>
+              </a:rPr>
+              <a:t>and neighborhood access</a:t>
+            </a:r>
+          </a:p>
+          <a:p xmlns:a="http://schemas.openxmlformats.org/drawingml/2006/main">
             <a:pPr>
+              <a:buNone/>
               <a:defRPr sz="2025" b="0">
                 <a:solidFill>
                   <a:srgbClr val="142E44"/>
@@ -8835,53 +9057,31 @@
                 <a:ea typeface="DejaVu Sans"/>
                 <a:cs typeface="DejaVu Sans"/>
               </a:rPr>
-              <a:t>Check rent and observed footfall</a:t>
-            </a:r>
-          </a:p>
-          <a:p xmlns:a="http://schemas.openxmlformats.org/drawingml/2006/main">
-            <a:pPr>
-              <a:defRPr sz="2025" b="0">
-                <a:solidFill>
-                  <a:srgbClr val="142E44"/>
-                </a:solidFill>
-                <a:latin typeface="DejaVu Sans"/>
-                <a:ea typeface="DejaVu Sans"/>
-                <a:cs typeface="DejaVu Sans"/>
-              </a:defRPr>
-            </a:pPr>
-            <a:r>
-              <a:rPr sz="2025" b="0">
-                <a:solidFill>
-                  <a:srgbClr val="142E44"/>
-                </a:solidFill>
-                <a:latin typeface="DejaVu Sans"/>
-                <a:ea typeface="DejaVu Sans"/>
-                <a:cs typeface="DejaVu Sans"/>
-              </a:rPr>
-              <a:t>Improve data coverage</a:t>
-            </a:r>
-          </a:p>
-          <a:p xmlns:a="http://schemas.openxmlformats.org/drawingml/2006/main">
-            <a:pPr>
-              <a:defRPr sz="2025" b="0">
-                <a:solidFill>
-                  <a:srgbClr val="142E44"/>
-                </a:solidFill>
-                <a:latin typeface="DejaVu Sans"/>
-                <a:ea typeface="DejaVu Sans"/>
-                <a:cs typeface="DejaVu Sans"/>
-              </a:defRPr>
-            </a:pPr>
-            <a:r>
-              <a:rPr sz="2025" b="0">
-                <a:solidFill>
-                  <a:srgbClr val="142E44"/>
-                </a:solidFill>
-                <a:latin typeface="DejaVu Sans"/>
-                <a:ea typeface="DejaVu Sans"/>
-                <a:cs typeface="DejaVu Sans"/>
-              </a:rPr>
-              <a:t>Use stronger spatial validation</a:t>
+              <a:t/>
+            </a:r>
+          </a:p>
+          <a:p xmlns:a="http://schemas.openxmlformats.org/drawingml/2006/main">
+            <a:pPr algn="l">
+              <a:buNone/>
+              <a:defRPr sz="1650" b="0">
+                <a:solidFill>
+                  <a:srgbClr val="142E44"/>
+                </a:solidFill>
+                <a:latin typeface="DejaVu Sans"/>
+                <a:ea typeface="DejaVu Sans"/>
+                <a:cs typeface="DejaVu Sans"/>
+              </a:defRPr>
+            </a:pPr>
+            <a:r>
+              <a:rPr sz="1650" b="0">
+                <a:solidFill>
+                  <a:srgbClr val="142E44"/>
+                </a:solidFill>
+                <a:latin typeface="DejaVu Sans"/>
+                <a:ea typeface="DejaVu Sans"/>
+                <a:cs typeface="DejaVu Sans"/>
+              </a:rPr>
+              <a:t>Safety and resilience need further data</a:t>
             </a:r>
           </a:p>
         </p:txBody>
@@ -8919,26 +9119,27 @@
           </a:bodyPr>
           <a:lstStyle xmlns:a="http://schemas.openxmlformats.org/drawingml/2006/main"/>
           <a:p xmlns:a="http://schemas.openxmlformats.org/drawingml/2006/main">
-            <a:pPr>
-              <a:defRPr sz="2025" b="1">
-                <a:solidFill>
-                  <a:srgbClr val="142E44"/>
-                </a:solidFill>
-                <a:latin typeface="DejaVu Sans"/>
-                <a:ea typeface="DejaVu Sans"/>
-                <a:cs typeface="DejaVu Sans"/>
-              </a:defRPr>
-            </a:pPr>
-            <a:r>
-              <a:rPr sz="2025" b="1">
-                <a:solidFill>
-                  <a:srgbClr val="142E44"/>
-                </a:solidFill>
-                <a:latin typeface="DejaVu Sans"/>
-                <a:ea typeface="DejaVu Sans"/>
-                <a:cs typeface="DejaVu Sans"/>
-              </a:rPr>
-              <a:t>Better-informed fieldwork begins with an explainable shortlist.</a:t>
+            <a:pPr algn="l">
+              <a:buNone/>
+              <a:defRPr sz="1725" b="1">
+                <a:solidFill>
+                  <a:srgbClr val="142E44"/>
+                </a:solidFill>
+                <a:latin typeface="DejaVu Sans"/>
+                <a:ea typeface="DejaVu Sans"/>
+                <a:cs typeface="DejaVu Sans"/>
+              </a:defRPr>
+            </a:pPr>
+            <a:r>
+              <a:rPr sz="1725" b="1">
+                <a:solidFill>
+                  <a:srgbClr val="142E44"/>
+                </a:solidFill>
+                <a:latin typeface="DejaVu Sans"/>
+                <a:ea typeface="DejaVu Sans"/>
+                <a:cs typeface="DejaVu Sans"/>
+              </a:rPr>
+              <a:t>Health, employment and urban outcomes have not been measured.</a:t>
             </a:r>
           </a:p>
         </p:txBody>

</xml_diff>